<commit_message>
Update Co-Authored-By: Claude Haiku 4.5 <noreply@anthropic.com> Claude-Session: https://claude.ai/code/session_012L8Wdei7z9r95cU7BJmhi4
</commit_message>
<xml_diff>
--- a/Lite-KB_Graph_RAG_Plugin (1).pptx
+++ b/Lite-KB_Graph_RAG_Plugin (1).pptx
@@ -15,9 +15,10 @@
     <p:sldId id="263" r:id="rId9"/>
     <p:sldId id="264" r:id="rId10"/>
     <p:sldId id="265" r:id="rId11"/>
+    <p:sldId id="266" r:id="rId12"/>
   </p:sldIdLst>
   <p:notesMasterIdLst>
-    <p:notesMasterId r:id="rId12"/>
+    <p:notesMasterId r:id="rId13"/>
   </p:notesMasterIdLst>
   <p:sldSz cx="12192000" cy="6858000"/>
   <p:notesSz cx="6858000" cy="12192000"/>
@@ -511,7 +512,8 @@
           <a:p>
             <a:r>
               <a:rPr lang="en-US" dirty="0"/>
-              <a:t>Lite-KB: a graph RAG plugin for LiteAi. Ingests Signavio BPMN + spec decks + documents. Fully local, deterministic on structure, citations on everything. Pilot already validated — asking to publish.</a:t>
+              <a:t>OPEN (30 sec): Lite-KB is a graph-RAG plugin for LiteAi that turns our whole Signavio repository and specification decks into an assistant that answers process questions instantly — with an exact citation on every answer. Structural questions are answered deterministically from a graph database, so hallucination is impossible by design. It runs local-first, uses only the official corporate AI, and has already been validated by the process owner and the chief architect. Today I am asking for approval to publish it on the LiteAi marketplace.
+NAMING: Lite-KB = the knowledge base plugin; ppt_parser = the deep PowerPoint extraction engine behind it.</a:t>
             </a:r>
             <a:endParaRPr lang="en-US" dirty="0"/>
           </a:p>
@@ -599,8 +601,10 @@
           <a:p>
             <a:r>
               <a:rPr lang="en-US" dirty="0"/>
-              <a:t>Phase 1 done and validated. Lite-KB is already staged on a LiteAi marketplace branch — publishing is one approval away. Ask: green light + prioritization of next documents. Phase 3 unlocks audit-grade compliance reporting.
-If asked about images / scanned content: images are not parsed yet — planned for Phase 2 (OCR). Process diagrams are NOT affected: Signavio is ingested as structured BPMN 2.0 XML, not as pictures — which is exactly why structural answers are deterministic.</a:t>
+              <a:t>SAY: Phase 1 is done and validated. Lite-KB is already staged on a LiteAi marketplace branch — publishing is one approval away. The ask: green light plus prioritization of the next process documents. Phase 3 unlocks audit-grade compliance reporting.
+OWNERSHIP (prepare your own answer — suggested framing): I maintain it as plugin owner with phase-gated, test-gated releases; ingestion and sync are automated, so steady-state effort is low; the marketplace gives a controlled update channel.
+STALENESS IF ASKED: today re-sync runs on demand with incremental hash diffing (unchanged models are never re-indexed); background live sync is a Phase 2 item.
+IF ASKED about images: not parsed yet — Phase 2 (OCR); Signavio diagrams unaffected (BPMN XML, not pictures).</a:t>
             </a:r>
             <a:endParaRPr lang="en-US" dirty="0"/>
           </a:p>
@@ -624,6 +628,105 @@
             <a:fld id="{F7021451-1387-4CA6-816F-3879F97B5CBC}" type="slidenum">
               <a:rPr lang="en-US"/>
               <a:t>10</a:t>
+            </a:fld>
+            <a:endParaRPr lang="en-US"/>
+          </a:p>
+        </p:txBody>
+      </p:sp>
+    </p:spTree>
+    <p:extLst>
+      <p:ext uri="{BB962C8B-B14F-4D97-AF65-F5344CB8AC3E}">
+        <p14:creationId xmlns:p14="http://schemas.microsoft.com/office/powerpoint/2010/main" val="1024086991"/>
+      </p:ext>
+    </p:extLst>
+  </p:cSld>
+  <p:clrMapOvr>
+    <a:masterClrMapping/>
+  </p:clrMapOvr>
+</p:notes>
+</file>
+
+<file path=ppt/notesSlides/notesSlide11.xml><?xml version="1.0" encoding="utf-8"?>
+<p:notes xmlns:a="http://schemas.openxmlformats.org/drawingml/2006/main" xmlns:r="http://schemas.openxmlformats.org/officeDocument/2006/relationships" xmlns:p="http://schemas.openxmlformats.org/presentationml/2006/main">
+  <p:cSld>
+    <p:spTree>
+      <p:nvGrpSpPr>
+        <p:cNvPr id="1" name=""/>
+        <p:cNvGrpSpPr/>
+        <p:nvPr/>
+      </p:nvGrpSpPr>
+      <p:grpSpPr>
+        <a:xfrm>
+          <a:off x="0" y="0"/>
+          <a:ext cx="0" cy="0"/>
+          <a:chOff x="0" y="0"/>
+          <a:chExt cx="0" cy="0"/>
+        </a:xfrm>
+      </p:grpSpPr>
+      <p:sp>
+        <p:nvSpPr>
+          <p:cNvPr id="2" name="Slide Image Placeholder 1"/>
+          <p:cNvSpPr>
+            <a:spLocks noGrp="1" noRot="1" noChangeAspect="1"/>
+          </p:cNvSpPr>
+          <p:nvPr>
+            <p:ph type="sldImg"/>
+          </p:nvPr>
+        </p:nvSpPr>
+        <p:spPr/>
+      </p:sp>
+      <p:sp>
+        <p:nvSpPr>
+          <p:cNvPr id="3" name="Notes Placeholder 2"/>
+          <p:cNvSpPr>
+            <a:spLocks noGrp="1"/>
+          </p:cNvSpPr>
+          <p:nvPr>
+            <p:ph type="body" idx="1"/>
+          </p:nvPr>
+        </p:nvSpPr>
+        <p:spPr/>
+        <p:txBody>
+          <a:bodyPr/>
+          <a:lstStyle/>
+          <a:p>
+            <a:r>
+              <a:rPr lang="en-US" dirty="0"/>
+              <a:t>MASTER Q&amp;A CHEAT SHEET — usable anywhere in the meeting:
+1. Proof of accuracy? → 3 validators, 7 incremental sessions, 97.8% automated eval (question set available to open live).
+2. What if it answers wrong in an audit? → structural answers are deterministic; every answer carries a citation; the tool is complementary — humans verify at the official source, so it cannot create or hide defects.
+3. Does data leave the company? → retrieval is fully local; narrative goes only through the official corporate Gemini via LiteAi — never an unapproved service.
+4. Why not the Gemini gem alone? → capped at ~10 documents; Lite-KB works at repository scale and feeds the corporate AI curated, cited context.
+5. Why not wait for SAP Signavio AI? → cloud-side, not LiteAi-native, and cannot join decks + requirement matrices with our processes; Lite-KB is local and already validated.
+6. Can I query inside an embedded Excel? → today isolated &amp; position-stamped; content parsing is Phase 2 — already on the roadmap slide.
+7. Images / scanned pages? → OCR is Phase 2 (candidates already detected and queued); Signavio arrives as BPMN XML, so diagrams are unaffected.
+8. Who maintains it? → give your ownership answer (suggested: plugin owner = me, phase-gated test-gated releases, low steady-state effort, marketplace as controlled update channel).
+9. What does it cost? → no server, no cloud spend, zero tokens for structural queries; the cost is maintenance time.
+10. Security review? → hardened pipeline (XXE off, zip-bomb/zip-slip checks, magic-byte routing); I invite a formal review before release.
+CREDIBILITY CLOSER: every slide claim was cross-checked against the codebase; the verification matrix is available on request.</a:t>
+            </a:r>
+            <a:endParaRPr lang="en-US" dirty="0"/>
+          </a:p>
+        </p:txBody>
+      </p:sp>
+      <p:sp>
+        <p:nvSpPr>
+          <p:cNvPr id="4" name="Slide Number Placeholder 3"/>
+          <p:cNvSpPr>
+            <a:spLocks noGrp="1"/>
+          </p:cNvSpPr>
+          <p:nvPr>
+            <p:ph type="sldNum" sz="quarter" idx="10"/>
+          </p:nvPr>
+        </p:nvSpPr>
+        <p:spPr/>
+        <p:txBody>
+          <a:bodyPr/>
+          <a:lstStyle/>
+          <a:p>
+            <a:fld id="{F7021451-1387-4CA6-816F-3879F97B5CBC}" type="slidenum">
+              <a:rPr lang="en-US"/>
+              <a:t>11</a:t>
             </a:fld>
             <a:endParaRPr lang="en-US"/>
           </a:p>
@@ -688,7 +791,9 @@
           <a:p>
             <a:r>
               <a:rPr lang="en-US" dirty="0"/>
-              <a:t>Three failure modes: knowledge scattered, structure hallucinated, deep content lost. Estimate: 10-30 min per manual lookup.</a:t>
+              <a:t>SAY: three failure modes — knowledge scattered across systems, structure hallucinated by standard RAG, and deep content (SmartArt, charts, embedded files) invisible to flat parsers. The 10–30 min figure is an estimate — say so openly.
+IF ASKED why not search Signavio directly: portal search is per-model keyword search — it cannot join process models with spec decks, PDFs or requirement matrices, and gives no cross-source citations.
+IF ASKED why not the corporate AI directly: the official Gemini gem is capped at ~10 documents — it cannot hold the repository. Full answer on the backup slide.</a:t>
             </a:r>
             <a:endParaRPr lang="en-US" dirty="0"/>
           </a:p>
@@ -776,7 +881,9 @@
           <a:p>
             <a:r>
               <a:rPr lang="en-US" dirty="0"/>
-              <a:t>One plugin, two answer paths: deterministic graph for structure, hybrid retrieval for narrative. Everything lands in an embedded ArcadeDB. Ingestion: Signavio MCP sync with diffing, deep pptx parser, doc pipeline.</a:t>
+              <a:t>WALKTHROUGH (30 sec): a question enters through LiteAi → the router classifies it → structural questions go to the graph engine (pure database work, no LLM) → narrative questions go to hybrid retrieval (local vectors + BM25 keyword, RRF fusion, cross-encoder rerank) → both read one embedded ArcadeDB → every answer returns with its citation.
+WHY THIS STACK: ArcadeDB = graph + vector + documents in ONE embedded database, nothing to operate; FastMCP = standard protocol, so any agent or harness can call the same tools.
+BOUNDARY IF ASKED: retrieval, reranking and graph answers are fully local; narrative text generation goes only through Gemini — the official corporate AI — inside LiteAi. No unapproved external service anywhere.</a:t>
             </a:r>
             <a:endParaRPr lang="en-US" dirty="0"/>
           </a:p>
@@ -864,7 +971,9 @@
           <a:p>
             <a:r>
               <a:rPr lang="en-US" dirty="0"/>
-              <a:t>Key differentiator: for audit-critical structural questions the LLM is bypassed entirely. 100% accuracy by construction, zero token cost, bounded subgraph answers.</a:t>
+              <a:t>SAY: the audit-critical questions — who is responsible, what comes next, step order, branch conditions — never touch an LLM. They are answered straight from BPMN nodes in the database. Zero hallucination is a design property here, not a promise.
+IF ASKED what if the router misroutes a structural question: worst case it falls to the hybrid route, which still returns pre-stamped, cited passages — the user verifies at the source; the structural tools can also be invoked explicitly. Router rules are deterministic intent patterns and are testable.
+EXTRA: hops=3 keeps graph answers as small verified subgraphs instead of dumping 100-step processes into context.</a:t>
             </a:r>
             <a:endParaRPr lang="en-US" dirty="0"/>
           </a:p>
@@ -952,7 +1061,9 @@
           <a:p>
             <a:r>
               <a:rPr lang="en-US" dirty="0"/>
-              <a:t>Citations are never generated: they are captured at parse time and travel inside the chunk. UID lookups are exact SQL joins. Printed vs physical slide numbers reconciled.</a:t>
+              <a:t>SAY: citations are captured at parse time and physically travel inside each chunk — the LLM never invents them. Requirement IDs resolve through an exact SQL join, not through ranking.
+IF ASKED what happens when a source document changes: incremental sync recomputes revisions by hash diff, so citations always reflect the currently ingested version; unchanged models are not re-indexed.
+EXTRA: printed vs physical slide numbers are reconciled — a cited slide number matches what the reader actually sees in the deck or PDF export.</a:t>
             </a:r>
             <a:endParaRPr lang="en-US" dirty="0"/>
           </a:p>
@@ -1040,8 +1151,10 @@
           <a:p>
             <a:r>
               <a:rPr lang="en-US" dirty="0"/>
-              <a:t>ppt_parser goes below the abstractions: geometry-based reading order, SmartArt, chart XML, embedded OLE payloads, UID preservation. Ingestion is hardened against document-based attacks and resumable at scale.
-If asked “what about pictures / scans?”: raw images are not read yet (OCR is Phase 2). Process diagrams are unaffected — Signavio exports structured BPMN 2.0 XML, so diagrams come in as data, not images.</a:t>
+              <a:t>SAY: ppt_parser goes below the standard abstractions — geometry-based reading order, SmartArt from DrawingML, chart data from cached XML, OLE payload isolation, UID preservation. Ingestion is hardened and resumable at scale.
+BE PRECISE IF ASKED: embedded Excel/Word/PDF payloads are today ISOLATED into the AssetStore and position-stamped — their inner content gets parsed in Phase 2.
+IF ASKED about pictures / scans: raw images are not read yet (OCR is Phase 2 — the code already detects and queues OCR candidates). Process diagrams are unaffected: Signavio exports structured BPMN 2.0 XML, so diagrams arrive as data, not images.
+EXTRA: legacy binary .ppt files are detected by magic bytes and converted through a bundled LibreOffice step before parsing.</a:t>
             </a:r>
             <a:endParaRPr lang="en-US" dirty="0"/>
           </a:p>
@@ -1129,7 +1242,9 @@
           <a:p>
             <a:r>
               <a:rPr lang="en-US" dirty="0"/>
-              <a:t>Two properties management cares about: cost discipline (token optimizations, zero-token structural path) and governance (fully local, air-gapped, hardened).</a:t>
+              <a:t>SAY: two properties management cares about — cost discipline and governance. Boundary stated precisely: search, reranking and graph answers are 100% local; narrative generation runs only through Gemini, the official approved AI tool, via LiteAi.
+COST IF ASKED: no server to run, no cloud spend, zero tokens on structural queries; deployment is a local plugin with pre-bundled models. The main ongoing cost is maintenance effort, which is phase-gated.
+SECURITY REVIEW IF ASKED: the pipeline is hardened (XXE disabled, zip-bomb/zip-slip validation, magic-byte routing) and I welcome a formal security review before the marketplace release.</a:t>
             </a:r>
             <a:endParaRPr lang="en-US" dirty="0"/>
           </a:p>
@@ -1217,8 +1332,9 @@
           <a:p>
             <a:r>
               <a:rPr lang="en-US" dirty="0"/>
-              <a:t>Not theoretical: full Signavio repo + Dictionary Index, SWE.1 &amp; SWE.2 structured, validated by the process owner (Amr Mohamed) and the chief architect in Cairo (Wael Kadry). Impact figures are estimates, to be measured in rollout.
-Anecdote to tell live: Wael installed the plugin himself in minutes — all he had to enter was his username and password; libraries and setup were fully automatic. He was impressed by how direct the installation was.</a:t>
+              <a:t>SAY: real scope, real sign-off. Amr Mohamed ran 7 incremental sessions phase by phase (Signavio export → retrieval → Dictionary → documents); Wael Kadry spot-checked traceability with targeted questions; Abdelrahman Abbas independently checked process Q&amp;A.
+EVAL DEFENSE (97.8%): automated AI-judged evaluation — 20 generated questions per document, incl. needle-in-haystack and multi-document multi-hop retrieval. The full question set and results are available to open on the spot; every phase gets the same test gate, incl. Phase 2.
+ANECDOTE TO TELL LIVE: Wael installed the plugin himself in minutes — he only entered his username and password; libraries and setup were fully automatic. He was impressed by how direct it was.</a:t>
             </a:r>
             <a:endParaRPr lang="en-US" dirty="0"/>
           </a:p>
@@ -1306,7 +1422,8 @@
           <a:p>
             <a:r>
               <a:rPr lang="en-US" dirty="0"/>
-              <a:t>Condensed capability matrix: everything a standard pipeline loses, Lite-KB keeps — deterministically.</a:t>
+              <a:t>SAY: everything a standard pipeline loses, Lite-KB keeps — deterministically. The two rows that matter most for us are Step order &amp; RACI and Citations: those are the audit-critical ones.
+CREDIBILITY: every row was cross-checked against the actual codebase — a code-vs-slide verification matrix is available on request.</a:t>
             </a:r>
             <a:endParaRPr lang="en-US" dirty="0"/>
           </a:p>
@@ -2288,7 +2405,7 @@
                 <a:ea typeface="Arial" pitchFamily="34" charset="-122"/>
                 <a:cs typeface="Arial" pitchFamily="34" charset="-120"/>
               </a:rPr>
-              <a:t>Deterministic, fully local process intelligence over Signavio BPMN models and specification decks — with audit-grade citations on every answer.</a:t>
+              <a:t>Deterministic, local-first process intelligence over Signavio BPMN models and specification decks — with audit-grade citations on every answer.</a:t>
             </a:r>
             <a:endParaRPr lang="en-US" sz="1500" dirty="0"/>
           </a:p>
@@ -2303,7 +2420,7 @@
         <p:spPr>
           <a:xfrm>
             <a:off x="685800" y="4526280"/>
-            <a:ext cx="2788920" cy="475488"/>
+            <a:ext cx="3063240" cy="475488"/>
           </a:xfrm>
           <a:prstGeom prst="roundRect">
             <a:avLst>
@@ -2325,7 +2442,7 @@
         <p:spPr>
           <a:xfrm>
             <a:off x="685800" y="4526280"/>
-            <a:ext cx="2788920" cy="475488"/>
+            <a:ext cx="3063240" cy="475488"/>
           </a:xfrm>
           <a:prstGeom prst="rect">
             <a:avLst/>
@@ -2349,7 +2466,7 @@
                 <a:ea typeface="Arial" pitchFamily="34" charset="-122"/>
                 <a:cs typeface="Arial" pitchFamily="34" charset="-120"/>
               </a:rPr>
-              <a:t>100% local &amp; air-gapped</a:t>
+              <a:t>Local retrieval · official corporate AI</a:t>
             </a:r>
             <a:endParaRPr lang="en-US" sz="1150" dirty="0"/>
           </a:p>
@@ -2363,7 +2480,7 @@
         </p:nvSpPr>
         <p:spPr>
           <a:xfrm>
-            <a:off x="3749040" y="4526280"/>
+            <a:off x="4023360" y="4526280"/>
             <a:ext cx="3794760" cy="475488"/>
           </a:xfrm>
           <a:prstGeom prst="roundRect">
@@ -2385,7 +2502,7 @@
         </p:nvSpPr>
         <p:spPr>
           <a:xfrm>
-            <a:off x="3749040" y="4526280"/>
+            <a:off x="4023360" y="4526280"/>
             <a:ext cx="3794760" cy="475488"/>
           </a:xfrm>
           <a:prstGeom prst="rect">
@@ -2424,7 +2541,7 @@
         </p:nvSpPr>
         <p:spPr>
           <a:xfrm>
-            <a:off x="7818120" y="4526280"/>
+            <a:off x="8092440" y="4526280"/>
             <a:ext cx="3383280" cy="475488"/>
           </a:xfrm>
           <a:prstGeom prst="roundRect">
@@ -2446,7 +2563,7 @@
         </p:nvSpPr>
         <p:spPr>
           <a:xfrm>
-            <a:off x="7818120" y="4526280"/>
+            <a:off x="8092440" y="4526280"/>
             <a:ext cx="3383280" cy="475488"/>
           </a:xfrm>
           <a:prstGeom prst="rect">
@@ -2835,7 +2952,7 @@
                 <a:ea typeface="Arial" pitchFamily="34" charset="-122"/>
                 <a:cs typeface="Arial" pitchFamily="34" charset="-120"/>
               </a:rPr>
-              <a:t>Ingest SOPs, PDF &amp; Word procedures; add image / OCR ingestion; expand trace graphs between SWE.1 / SWE.2 specs and engineering SOPs; background live sync.</a:t>
+              <a:t>Ingest SOPs, PDF &amp; Word procedures; parse embedded file payloads; add image / OCR ingestion; expand SWE.1 / SWE.2 trace graphs to engineering SOPs; background live sync.</a:t>
             </a:r>
             <a:endParaRPr lang="en-US" sz="1180" dirty="0"/>
           </a:p>
@@ -3070,6 +3187,725 @@
               <a:t>approval to publish — Lite-KB is already staged on a LiteAi marketplace branch — plus a prioritized list of the next process documents for Phase 2.</a:t>
             </a:r>
             <a:endParaRPr lang="en-US" sz="1600" dirty="0"/>
+          </a:p>
+        </p:txBody>
+      </p:sp>
+    </p:spTree>
+  </p:cSld>
+  <p:clrMapOvr>
+    <a:masterClrMapping/>
+  </p:clrMapOvr>
+</p:sld>
+</file>
+
+<file path=ppt/slides/slide11.xml><?xml version="1.0" encoding="utf-8"?>
+<p:sld xmlns:a="http://schemas.openxmlformats.org/drawingml/2006/main" xmlns:r="http://schemas.openxmlformats.org/officeDocument/2006/relationships" xmlns:p="http://schemas.openxmlformats.org/presentationml/2006/main">
+  <p:cSld name="Slide 11">
+    <p:spTree>
+      <p:nvGrpSpPr>
+        <p:cNvPr id="1" name=""/>
+        <p:cNvGrpSpPr/>
+        <p:nvPr/>
+      </p:nvGrpSpPr>
+      <p:grpSpPr>
+        <a:xfrm>
+          <a:off x="0" y="0"/>
+          <a:ext cx="0" cy="0"/>
+          <a:chOff x="0" y="0"/>
+          <a:chExt cx="0" cy="0"/>
+        </a:xfrm>
+      </p:grpSpPr>
+      <p:sp>
+        <p:nvSpPr>
+          <p:cNvPr id="2" name="Text 0"/>
+          <p:cNvSpPr txBox="1"/>
+          <p:nvPr/>
+        </p:nvSpPr>
+        <p:spPr>
+          <a:xfrm>
+            <a:off x="548640" y="274320"/>
+            <a:ext cx="11091672" cy="594360"/>
+          </a:xfrm>
+          <a:prstGeom prst="rect">
+            <a:avLst/>
+          </a:prstGeom>
+          <a:noFill/>
+          <a:ln/>
+        </p:spPr>
+        <p:txBody>
+          <a:bodyPr wrap="square" lIns="0" tIns="0" rIns="0" bIns="0" rtlCol="0" anchor="ctr"/>
+          <a:lstStyle/>
+          <a:p>
+            <a:pPr indent="0" marL="0">
+              <a:buNone/>
+            </a:pPr>
+            <a:r>
+              <a:rPr lang="en-US" sz="2700" b="1" dirty="0">
+                <a:solidFill>
+                  <a:srgbClr val="1B2A35"/>
+                </a:solidFill>
+                <a:latin typeface="Arial" pitchFamily="34" charset="0"/>
+                <a:ea typeface="Arial" pitchFamily="34" charset="-122"/>
+                <a:cs typeface="Arial" pitchFamily="34" charset="-120"/>
+              </a:rPr>
+              <a:t>Backup — evidence &amp; governance</a:t>
+            </a:r>
+            <a:endParaRPr lang="en-US" sz="2700" dirty="0"/>
+          </a:p>
+        </p:txBody>
+      </p:sp>
+      <p:sp>
+        <p:nvSpPr>
+          <p:cNvPr id="3" name="Shape 1"/>
+          <p:cNvSpPr/>
+          <p:nvPr/>
+        </p:nvSpPr>
+        <p:spPr>
+          <a:xfrm>
+            <a:off x="548640" y="1280160"/>
+            <a:ext cx="5394960" cy="2514600"/>
+          </a:xfrm>
+          <a:prstGeom prst="roundRect">
+            <a:avLst>
+              <a:gd name="adj" fmla="val 3636"/>
+            </a:avLst>
+          </a:prstGeom>
+          <a:solidFill>
+            <a:srgbClr val="FBFCFD"/>
+          </a:solidFill>
+          <a:ln w="12700">
+            <a:solidFill>
+              <a:srgbClr val="D7E0E6"/>
+            </a:solidFill>
+            <a:prstDash val="solid"/>
+          </a:ln>
+        </p:spPr>
+      </p:sp>
+      <p:sp>
+        <p:nvSpPr>
+          <p:cNvPr id="4" name="Shape 2"/>
+          <p:cNvSpPr/>
+          <p:nvPr/>
+        </p:nvSpPr>
+        <p:spPr>
+          <a:xfrm>
+            <a:off x="804672" y="1536192"/>
+            <a:ext cx="475488" cy="475488"/>
+          </a:xfrm>
+          <a:prstGeom prst="roundRect">
+            <a:avLst>
+              <a:gd name="adj" fmla="val 17308"/>
+            </a:avLst>
+          </a:prstGeom>
+          <a:solidFill>
+            <a:srgbClr val="E4F2F0"/>
+          </a:solidFill>
+          <a:ln/>
+        </p:spPr>
+      </p:sp>
+      <p:pic>
+        <p:nvPicPr>
+          <p:cNvPr id="5" name="Image 0" descr="icons/FiTarget_028090.png">    </p:cNvPr>
+          <p:cNvPicPr>
+            <a:picLocks noChangeAspect="1"/>
+          </p:cNvPicPr>
+          <p:nvPr/>
+        </p:nvPicPr>
+        <p:blipFill>
+          <a:blip r:embed="rId1"/>
+          <a:stretch>
+            <a:fillRect/>
+          </a:stretch>
+        </p:blipFill>
+        <p:spPr>
+          <a:xfrm>
+            <a:off x="899770" y="1631290"/>
+            <a:ext cx="285293" cy="285293"/>
+          </a:xfrm>
+          <a:prstGeom prst="rect">
+            <a:avLst/>
+          </a:prstGeom>
+        </p:spPr>
+      </p:pic>
+      <p:sp>
+        <p:nvSpPr>
+          <p:cNvPr id="6" name="Text 3"/>
+          <p:cNvSpPr txBox="1"/>
+          <p:nvPr/>
+        </p:nvSpPr>
+        <p:spPr>
+          <a:xfrm>
+            <a:off x="1444752" y="1517904"/>
+            <a:ext cx="4251960" cy="329184"/>
+          </a:xfrm>
+          <a:prstGeom prst="rect">
+            <a:avLst/>
+          </a:prstGeom>
+          <a:noFill/>
+          <a:ln/>
+        </p:spPr>
+        <p:txBody>
+          <a:bodyPr wrap="square" lIns="0" tIns="0" rIns="0" bIns="0" rtlCol="0" anchor="ctr"/>
+          <a:lstStyle/>
+          <a:p>
+            <a:pPr indent="0" marL="0">
+              <a:buNone/>
+            </a:pPr>
+            <a:r>
+              <a:rPr lang="en-US" sz="1400" b="1" dirty="0">
+                <a:solidFill>
+                  <a:srgbClr val="1B2A35"/>
+                </a:solidFill>
+                <a:latin typeface="Arial" pitchFamily="34" charset="0"/>
+                <a:ea typeface="Arial" pitchFamily="34" charset="-122"/>
+                <a:cs typeface="Arial" pitchFamily="34" charset="-120"/>
+              </a:rPr>
+              <a:t>How it was tested</a:t>
+            </a:r>
+            <a:endParaRPr lang="en-US" sz="1400" dirty="0"/>
+          </a:p>
+        </p:txBody>
+      </p:sp>
+      <p:sp>
+        <p:nvSpPr>
+          <p:cNvPr id="7" name="Text 4"/>
+          <p:cNvSpPr txBox="1"/>
+          <p:nvPr/>
+        </p:nvSpPr>
+        <p:spPr>
+          <a:xfrm>
+            <a:off x="914400" y="1993392"/>
+            <a:ext cx="4663440" cy="1600200"/>
+          </a:xfrm>
+          <a:prstGeom prst="rect">
+            <a:avLst/>
+          </a:prstGeom>
+          <a:noFill/>
+          <a:ln/>
+        </p:spPr>
+        <p:txBody>
+          <a:bodyPr wrap="square" lIns="0" tIns="0" rIns="0" bIns="0" rtlCol="0" anchor="ctr"/>
+          <a:lstStyle/>
+          <a:p>
+            <a:pPr indent="0" marL="0">
+              <a:lnSpc>
+                <a:spcPct val="112000"/>
+              </a:lnSpc>
+              <a:buNone/>
+            </a:pPr>
+            <a:r>
+              <a:rPr lang="en-US" sz="1030" dirty="0">
+                <a:solidFill>
+                  <a:srgbClr val="3A4A55"/>
+                </a:solidFill>
+                <a:latin typeface="Arial" pitchFamily="34" charset="0"/>
+                <a:ea typeface="Arial" pitchFamily="34" charset="-122"/>
+                <a:cs typeface="Arial" pitchFamily="34" charset="-120"/>
+              </a:rPr>
+              <a:t>Phase-gated: 7 incremental sessions by the process owner (Signavio export → retrieval, Dictionary Index, process documents), plus independent spot checks by Wael Kadry and Abdelrahman Abbas. Development eval: 20 AI-generated questions per document — incl. needle-in-haystack and multi-document, multi-hop retrieval → 97.8% accuracy (automated AI-judged evaluation; question set available). Each next phase gets the same test gate.</a:t>
+            </a:r>
+            <a:endParaRPr lang="en-US" sz="1030" dirty="0"/>
+          </a:p>
+        </p:txBody>
+      </p:sp>
+      <p:sp>
+        <p:nvSpPr>
+          <p:cNvPr id="8" name="Shape 5"/>
+          <p:cNvSpPr/>
+          <p:nvPr/>
+        </p:nvSpPr>
+        <p:spPr>
+          <a:xfrm>
+            <a:off x="6245352" y="1280160"/>
+            <a:ext cx="5394960" cy="2514600"/>
+          </a:xfrm>
+          <a:prstGeom prst="roundRect">
+            <a:avLst>
+              <a:gd name="adj" fmla="val 3636"/>
+            </a:avLst>
+          </a:prstGeom>
+          <a:solidFill>
+            <a:srgbClr val="FBFCFD"/>
+          </a:solidFill>
+          <a:ln w="12700">
+            <a:solidFill>
+              <a:srgbClr val="D7E0E6"/>
+            </a:solidFill>
+            <a:prstDash val="solid"/>
+          </a:ln>
+        </p:spPr>
+      </p:sp>
+      <p:sp>
+        <p:nvSpPr>
+          <p:cNvPr id="9" name="Shape 6"/>
+          <p:cNvSpPr/>
+          <p:nvPr/>
+        </p:nvSpPr>
+        <p:spPr>
+          <a:xfrm>
+            <a:off x="6501384" y="1536192"/>
+            <a:ext cx="475488" cy="475488"/>
+          </a:xfrm>
+          <a:prstGeom prst="roundRect">
+            <a:avLst>
+              <a:gd name="adj" fmla="val 17308"/>
+            </a:avLst>
+          </a:prstGeom>
+          <a:solidFill>
+            <a:srgbClr val="E4F2F0"/>
+          </a:solidFill>
+          <a:ln/>
+        </p:spPr>
+      </p:sp>
+      <p:pic>
+        <p:nvPicPr>
+          <p:cNvPr id="10" name="Image 1" descr="icons/FiShield_028090.png">    </p:cNvPr>
+          <p:cNvPicPr>
+            <a:picLocks noChangeAspect="1"/>
+          </p:cNvPicPr>
+          <p:nvPr/>
+        </p:nvPicPr>
+        <p:blipFill>
+          <a:blip r:embed="rId2"/>
+          <a:stretch>
+            <a:fillRect/>
+          </a:stretch>
+        </p:blipFill>
+        <p:spPr>
+          <a:xfrm>
+            <a:off x="6596482" y="1631290"/>
+            <a:ext cx="285293" cy="285293"/>
+          </a:xfrm>
+          <a:prstGeom prst="rect">
+            <a:avLst/>
+          </a:prstGeom>
+        </p:spPr>
+      </p:pic>
+      <p:sp>
+        <p:nvSpPr>
+          <p:cNvPr id="11" name="Text 7"/>
+          <p:cNvSpPr txBox="1"/>
+          <p:nvPr/>
+        </p:nvSpPr>
+        <p:spPr>
+          <a:xfrm>
+            <a:off x="7141464" y="1517904"/>
+            <a:ext cx="4251960" cy="329184"/>
+          </a:xfrm>
+          <a:prstGeom prst="rect">
+            <a:avLst/>
+          </a:prstGeom>
+          <a:noFill/>
+          <a:ln/>
+        </p:spPr>
+        <p:txBody>
+          <a:bodyPr wrap="square" lIns="0" tIns="0" rIns="0" bIns="0" rtlCol="0" anchor="ctr"/>
+          <a:lstStyle/>
+          <a:p>
+            <a:pPr indent="0" marL="0">
+              <a:buNone/>
+            </a:pPr>
+            <a:r>
+              <a:rPr lang="en-US" sz="1400" b="1" dirty="0">
+                <a:solidFill>
+                  <a:srgbClr val="1B2A35"/>
+                </a:solidFill>
+                <a:latin typeface="Arial" pitchFamily="34" charset="0"/>
+                <a:ea typeface="Arial" pitchFamily="34" charset="-122"/>
+                <a:cs typeface="Arial" pitchFamily="34" charset="-120"/>
+              </a:rPr>
+              <a:t>Process integrity</a:t>
+            </a:r>
+            <a:endParaRPr lang="en-US" sz="1400" dirty="0"/>
+          </a:p>
+        </p:txBody>
+      </p:sp>
+      <p:sp>
+        <p:nvSpPr>
+          <p:cNvPr id="12" name="Text 8"/>
+          <p:cNvSpPr txBox="1"/>
+          <p:nvPr/>
+        </p:nvSpPr>
+        <p:spPr>
+          <a:xfrm>
+            <a:off x="6611112" y="1993392"/>
+            <a:ext cx="4663440" cy="1600200"/>
+          </a:xfrm>
+          <a:prstGeom prst="rect">
+            <a:avLst/>
+          </a:prstGeom>
+          <a:noFill/>
+          <a:ln/>
+        </p:spPr>
+        <p:txBody>
+          <a:bodyPr wrap="square" lIns="0" tIns="0" rIns="0" bIns="0" rtlCol="0" anchor="ctr"/>
+          <a:lstStyle/>
+          <a:p>
+            <a:pPr indent="0" marL="0">
+              <a:lnSpc>
+                <a:spcPct val="112000"/>
+              </a:lnSpc>
+              <a:buNone/>
+            </a:pPr>
+            <a:r>
+              <a:rPr lang="en-US" sz="1030" dirty="0">
+                <a:solidFill>
+                  <a:srgbClr val="3A4A55"/>
+                </a:solidFill>
+                <a:latin typeface="Arial" pitchFamily="34" charset="0"/>
+                <a:ea typeface="Arial" pitchFamily="34" charset="-122"/>
+                <a:cs typeface="Arial" pitchFamily="34" charset="-120"/>
+              </a:rPr>
+              <a:t>Lite-KB is a complementary lookup tool, not a step of the process itself: it never creates, modifies or approves any deliverable, so it cannot introduce or hide defects. Every answer carries an exact citation, so users always verify against the official source.</a:t>
+            </a:r>
+            <a:endParaRPr lang="en-US" sz="1030" dirty="0"/>
+          </a:p>
+        </p:txBody>
+      </p:sp>
+      <p:sp>
+        <p:nvSpPr>
+          <p:cNvPr id="13" name="Shape 9"/>
+          <p:cNvSpPr/>
+          <p:nvPr/>
+        </p:nvSpPr>
+        <p:spPr>
+          <a:xfrm>
+            <a:off x="548640" y="3977640"/>
+            <a:ext cx="5394960" cy="2514600"/>
+          </a:xfrm>
+          <a:prstGeom prst="roundRect">
+            <a:avLst>
+              <a:gd name="adj" fmla="val 3636"/>
+            </a:avLst>
+          </a:prstGeom>
+          <a:solidFill>
+            <a:srgbClr val="FBFCFD"/>
+          </a:solidFill>
+          <a:ln w="12700">
+            <a:solidFill>
+              <a:srgbClr val="D7E0E6"/>
+            </a:solidFill>
+            <a:prstDash val="solid"/>
+          </a:ln>
+        </p:spPr>
+      </p:sp>
+      <p:sp>
+        <p:nvSpPr>
+          <p:cNvPr id="14" name="Shape 10"/>
+          <p:cNvSpPr/>
+          <p:nvPr/>
+        </p:nvSpPr>
+        <p:spPr>
+          <a:xfrm>
+            <a:off x="804672" y="4233672"/>
+            <a:ext cx="475488" cy="475488"/>
+          </a:xfrm>
+          <a:prstGeom prst="roundRect">
+            <a:avLst>
+              <a:gd name="adj" fmla="val 17308"/>
+            </a:avLst>
+          </a:prstGeom>
+          <a:solidFill>
+            <a:srgbClr val="E4F2F0"/>
+          </a:solidFill>
+          <a:ln/>
+        </p:spPr>
+      </p:sp>
+      <p:pic>
+        <p:nvPicPr>
+          <p:cNvPr id="15" name="Image 2" descr="icons/FiLock_028090.png">    </p:cNvPr>
+          <p:cNvPicPr>
+            <a:picLocks noChangeAspect="1"/>
+          </p:cNvPicPr>
+          <p:nvPr/>
+        </p:nvPicPr>
+        <p:blipFill>
+          <a:blip r:embed="rId3"/>
+          <a:stretch>
+            <a:fillRect/>
+          </a:stretch>
+        </p:blipFill>
+        <p:spPr>
+          <a:xfrm>
+            <a:off x="899770" y="4328770"/>
+            <a:ext cx="285293" cy="285293"/>
+          </a:xfrm>
+          <a:prstGeom prst="rect">
+            <a:avLst/>
+          </a:prstGeom>
+        </p:spPr>
+      </p:pic>
+      <p:sp>
+        <p:nvSpPr>
+          <p:cNvPr id="16" name="Text 11"/>
+          <p:cNvSpPr txBox="1"/>
+          <p:nvPr/>
+        </p:nvSpPr>
+        <p:spPr>
+          <a:xfrm>
+            <a:off x="1444752" y="4215384"/>
+            <a:ext cx="4251960" cy="329184"/>
+          </a:xfrm>
+          <a:prstGeom prst="rect">
+            <a:avLst/>
+          </a:prstGeom>
+          <a:noFill/>
+          <a:ln/>
+        </p:spPr>
+        <p:txBody>
+          <a:bodyPr wrap="square" lIns="0" tIns="0" rIns="0" bIns="0" rtlCol="0" anchor="ctr"/>
+          <a:lstStyle/>
+          <a:p>
+            <a:pPr indent="0" marL="0">
+              <a:buNone/>
+            </a:pPr>
+            <a:r>
+              <a:rPr lang="en-US" sz="1400" b="1" dirty="0">
+                <a:solidFill>
+                  <a:srgbClr val="1B2A35"/>
+                </a:solidFill>
+                <a:latin typeface="Arial" pitchFamily="34" charset="0"/>
+                <a:ea typeface="Arial" pitchFamily="34" charset="-122"/>
+                <a:cs typeface="Arial" pitchFamily="34" charset="-120"/>
+              </a:rPr>
+              <a:t>Data &amp; access</a:t>
+            </a:r>
+            <a:endParaRPr lang="en-US" sz="1400" dirty="0"/>
+          </a:p>
+        </p:txBody>
+      </p:sp>
+      <p:sp>
+        <p:nvSpPr>
+          <p:cNvPr id="17" name="Text 12"/>
+          <p:cNvSpPr txBox="1"/>
+          <p:nvPr/>
+        </p:nvSpPr>
+        <p:spPr>
+          <a:xfrm>
+            <a:off x="914400" y="4690872"/>
+            <a:ext cx="4663440" cy="1600200"/>
+          </a:xfrm>
+          <a:prstGeom prst="rect">
+            <a:avLst/>
+          </a:prstGeom>
+          <a:noFill/>
+          <a:ln/>
+        </p:spPr>
+        <p:txBody>
+          <a:bodyPr wrap="square" lIns="0" tIns="0" rIns="0" bIns="0" rtlCol="0" anchor="ctr"/>
+          <a:lstStyle/>
+          <a:p>
+            <a:pPr indent="0" marL="0">
+              <a:lnSpc>
+                <a:spcPct val="112000"/>
+              </a:lnSpc>
+              <a:buNone/>
+            </a:pPr>
+            <a:r>
+              <a:rPr lang="en-US" sz="1030" dirty="0">
+                <a:solidFill>
+                  <a:srgbClr val="3A4A55"/>
+                </a:solidFill>
+                <a:latin typeface="Arial" pitchFamily="34" charset="0"/>
+                <a:ea typeface="Arial" pitchFamily="34" charset="-122"/>
+                <a:cs typeface="Arial" pitchFamily="34" charset="-120"/>
+              </a:rPr>
+              <a:t>Ingested process content is public within the company — no trade secrets or restricted material in the knowledge base. Retrieval runs locally on the user’s machine; narrative answers go only through the official corporate AI (Gemini), never unapproved services.</a:t>
+            </a:r>
+            <a:endParaRPr lang="en-US" sz="1030" dirty="0"/>
+          </a:p>
+        </p:txBody>
+      </p:sp>
+      <p:sp>
+        <p:nvSpPr>
+          <p:cNvPr id="18" name="Shape 13"/>
+          <p:cNvSpPr/>
+          <p:nvPr/>
+        </p:nvSpPr>
+        <p:spPr>
+          <a:xfrm>
+            <a:off x="6245352" y="3977640"/>
+            <a:ext cx="5394960" cy="2514600"/>
+          </a:xfrm>
+          <a:prstGeom prst="roundRect">
+            <a:avLst>
+              <a:gd name="adj" fmla="val 3636"/>
+            </a:avLst>
+          </a:prstGeom>
+          <a:solidFill>
+            <a:srgbClr val="FBFCFD"/>
+          </a:solidFill>
+          <a:ln w="12700">
+            <a:solidFill>
+              <a:srgbClr val="D7E0E6"/>
+            </a:solidFill>
+            <a:prstDash val="solid"/>
+          </a:ln>
+        </p:spPr>
+      </p:sp>
+      <p:sp>
+        <p:nvSpPr>
+          <p:cNvPr id="19" name="Shape 14"/>
+          <p:cNvSpPr/>
+          <p:nvPr/>
+        </p:nvSpPr>
+        <p:spPr>
+          <a:xfrm>
+            <a:off x="6501384" y="4233672"/>
+            <a:ext cx="475488" cy="475488"/>
+          </a:xfrm>
+          <a:prstGeom prst="roundRect">
+            <a:avLst>
+              <a:gd name="adj" fmla="val 17308"/>
+            </a:avLst>
+          </a:prstGeom>
+          <a:solidFill>
+            <a:srgbClr val="E4F2F0"/>
+          </a:solidFill>
+          <a:ln/>
+        </p:spPr>
+      </p:sp>
+      <p:pic>
+        <p:nvPicPr>
+          <p:cNvPr id="20" name="Image 3" descr="icons/FiDatabase_028090.png">    </p:cNvPr>
+          <p:cNvPicPr>
+            <a:picLocks noChangeAspect="1"/>
+          </p:cNvPicPr>
+          <p:nvPr/>
+        </p:nvPicPr>
+        <p:blipFill>
+          <a:blip r:embed="rId4"/>
+          <a:stretch>
+            <a:fillRect/>
+          </a:stretch>
+        </p:blipFill>
+        <p:spPr>
+          <a:xfrm>
+            <a:off x="6596482" y="4328770"/>
+            <a:ext cx="285293" cy="285293"/>
+          </a:xfrm>
+          <a:prstGeom prst="rect">
+            <a:avLst/>
+          </a:prstGeom>
+        </p:spPr>
+      </p:pic>
+      <p:sp>
+        <p:nvSpPr>
+          <p:cNvPr id="21" name="Text 15"/>
+          <p:cNvSpPr txBox="1"/>
+          <p:nvPr/>
+        </p:nvSpPr>
+        <p:spPr>
+          <a:xfrm>
+            <a:off x="7141464" y="4215384"/>
+            <a:ext cx="4251960" cy="329184"/>
+          </a:xfrm>
+          <a:prstGeom prst="rect">
+            <a:avLst/>
+          </a:prstGeom>
+          <a:noFill/>
+          <a:ln/>
+        </p:spPr>
+        <p:txBody>
+          <a:bodyPr wrap="square" lIns="0" tIns="0" rIns="0" bIns="0" rtlCol="0" anchor="ctr"/>
+          <a:lstStyle/>
+          <a:p>
+            <a:pPr indent="0" marL="0">
+              <a:buNone/>
+            </a:pPr>
+            <a:r>
+              <a:rPr lang="en-US" sz="1400" b="1" dirty="0">
+                <a:solidFill>
+                  <a:srgbClr val="1B2A35"/>
+                </a:solidFill>
+                <a:latin typeface="Arial" pitchFamily="34" charset="0"/>
+                <a:ea typeface="Arial" pitchFamily="34" charset="-122"/>
+                <a:cs typeface="Arial" pitchFamily="34" charset="-120"/>
+              </a:rPr>
+              <a:t>Why this stack</a:t>
+            </a:r>
+            <a:endParaRPr lang="en-US" sz="1400" dirty="0"/>
+          </a:p>
+        </p:txBody>
+      </p:sp>
+      <p:sp>
+        <p:nvSpPr>
+          <p:cNvPr id="22" name="Text 16"/>
+          <p:cNvSpPr txBox="1"/>
+          <p:nvPr/>
+        </p:nvSpPr>
+        <p:spPr>
+          <a:xfrm>
+            <a:off x="6611112" y="4690872"/>
+            <a:ext cx="4663440" cy="1600200"/>
+          </a:xfrm>
+          <a:prstGeom prst="rect">
+            <a:avLst/>
+          </a:prstGeom>
+          <a:noFill/>
+          <a:ln/>
+        </p:spPr>
+        <p:txBody>
+          <a:bodyPr wrap="square" lIns="0" tIns="0" rIns="0" bIns="0" rtlCol="0" anchor="ctr"/>
+          <a:lstStyle/>
+          <a:p>
+            <a:pPr indent="0" marL="0">
+              <a:lnSpc>
+                <a:spcPct val="112000"/>
+              </a:lnSpc>
+              <a:buNone/>
+            </a:pPr>
+            <a:r>
+              <a:rPr lang="en-US" sz="1030" dirty="0">
+                <a:solidFill>
+                  <a:srgbClr val="3A4A55"/>
+                </a:solidFill>
+                <a:latin typeface="Arial" pitchFamily="34" charset="0"/>
+                <a:ea typeface="Arial" pitchFamily="34" charset="-122"/>
+                <a:cs typeface="Arial" pitchFamily="34" charset="-120"/>
+              </a:rPr>
+              <a:t>ArcadeDB: native graph + vector in one embedded database — no server to operate, one-click install, auto-answer keeps token cost near zero. And why not the corporate AI alone? The official Gemini gem is capped at ~10 documents — far below our multi-hundred-slide corpus. Lite-KB is what lets the approved corporate AI work at repository scale.</a:t>
+            </a:r>
+            <a:endParaRPr lang="en-US" sz="1030" dirty="0"/>
+          </a:p>
+        </p:txBody>
+      </p:sp>
+      <p:sp>
+        <p:nvSpPr>
+          <p:cNvPr id="23" name="Text 17"/>
+          <p:cNvSpPr txBox="1"/>
+          <p:nvPr/>
+        </p:nvSpPr>
+        <p:spPr>
+          <a:xfrm>
+            <a:off x="11475720" y="6492240"/>
+            <a:ext cx="457200" cy="256032"/>
+          </a:xfrm>
+          <a:prstGeom prst="rect">
+            <a:avLst/>
+          </a:prstGeom>
+          <a:noFill/>
+          <a:ln/>
+        </p:spPr>
+        <p:txBody>
+          <a:bodyPr wrap="square" lIns="0" tIns="0" rIns="0" bIns="0" rtlCol="0" anchor="ctr"/>
+          <a:lstStyle/>
+          <a:p>
+            <a:pPr algn="r" indent="0" marL="0">
+              <a:buNone/>
+            </a:pPr>
+            <a:r>
+              <a:rPr lang="en-US" sz="900" dirty="0">
+                <a:solidFill>
+                  <a:srgbClr val="5C7080"/>
+                </a:solidFill>
+                <a:latin typeface="Arial" pitchFamily="34" charset="0"/>
+                <a:ea typeface="Arial" pitchFamily="34" charset="-122"/>
+                <a:cs typeface="Arial" pitchFamily="34" charset="-120"/>
+              </a:rPr>
+              <a:t>11</a:t>
+            </a:r>
+            <a:endParaRPr lang="en-US" sz="900" dirty="0"/>
           </a:p>
         </p:txBody>
       </p:sp>
@@ -4314,7 +5150,7 @@
                 <a:ea typeface="Arial" pitchFamily="34" charset="-122"/>
                 <a:cs typeface="Arial" pitchFamily="34" charset="-120"/>
               </a:rPr>
-              <a:t>ArcadeDB embedded store</a:t>
+              <a:t>ArcadeDB embedded graph-vector store</a:t>
             </a:r>
             <a:pPr algn="ctr" indent="0" marL="0">
               <a:lnSpc>
@@ -4340,7 +5176,7 @@
                 <a:ea typeface="Arial" pitchFamily="34" charset="-122"/>
                 <a:cs typeface="Arial" pitchFamily="34" charset="-120"/>
               </a:rPr>
-              <a:t>process graph edges + vector index + document chunks</a:t>
+              <a:t>process graph edges + JVector HNSW index + document chunks</a:t>
             </a:r>
             <a:endParaRPr lang="en-US" sz="1300" dirty="0"/>
           </a:p>
@@ -4554,7 +5390,7 @@
                 <a:ea typeface="Arial" pitchFamily="34" charset="-122"/>
                 <a:cs typeface="Arial" pitchFamily="34" charset="-120"/>
               </a:rPr>
-              <a:t>deep OOXML extraction</a:t>
+              <a:t>OOXML extraction · hardened security</a:t>
             </a:r>
             <a:endParaRPr lang="en-US" sz="1200" dirty="0"/>
           </a:p>
@@ -4719,7 +5555,7 @@
         </p:blipFill>
         <p:spPr>
           <a:xfrm>
-            <a:off x="4160520" y="6053328"/>
+            <a:off x="2331720" y="6053328"/>
             <a:ext cx="237744" cy="237744"/>
           </a:xfrm>
           <a:prstGeom prst="rect">
@@ -4735,8 +5571,8 @@
         </p:nvSpPr>
         <p:spPr>
           <a:xfrm>
-            <a:off x="4480560" y="6016752"/>
-            <a:ext cx="7132320" cy="320040"/>
+            <a:off x="2651760" y="6016752"/>
+            <a:ext cx="9006840" cy="320040"/>
           </a:xfrm>
           <a:prstGeom prst="rect">
             <a:avLst/>
@@ -4752,7 +5588,7 @@
               <a:buNone/>
             </a:pPr>
             <a:r>
-              <a:rPr lang="en-US" sz="1150" dirty="0">
+              <a:rPr lang="en-US" sz="1100" dirty="0">
                 <a:solidFill>
                   <a:srgbClr val="0B5563"/>
                 </a:solidFill>
@@ -4760,9 +5596,9 @@
                 <a:ea typeface="Arial" pitchFamily="34" charset="-122"/>
                 <a:cs typeface="Arial" pitchFamily="34" charset="-120"/>
               </a:rPr>
-              <a:t>Runs 100% locally — local embedding &amp; reranker models, no cloud APIs required.</a:t>
-            </a:r>
-            <a:endParaRPr lang="en-US" sz="1150" dirty="0"/>
+              <a:t>Retrieval, reranking &amp; graph answers run fully locally — narrative generation only via the official corporate AI (Gemini in LiteAi).</a:t>
+            </a:r>
+            <a:endParaRPr lang="en-US" sz="1100" dirty="0"/>
           </a:p>
         </p:txBody>
       </p:sp>
@@ -6906,7 +7742,7 @@
                 <a:ea typeface="Arial" pitchFamily="34" charset="-122"/>
                 <a:cs typeface="Arial" pitchFamily="34" charset="-120"/>
               </a:rPr>
-              <a:t>Embedded files recovered  —  </a:t>
+              <a:t>Embedded files isolated  —  </a:t>
             </a:r>
             <a:pPr indent="0" marL="0">
               <a:lnSpc>
@@ -6923,7 +7759,7 @@
                 <a:ea typeface="Arial" pitchFamily="34" charset="-122"/>
                 <a:cs typeface="Arial" pitchFamily="34" charset="-120"/>
               </a:rPr>
-              <a:t>Excel workbooks, Word docs and PDFs inside decks land in a SHA-256 content-addressed AssetStore and get parsed too.</a:t>
+              <a:t>Excel workbooks, Word docs and PDFs recovered into a SHA-256 AssetStore with deterministic location tokens — full content parsing staged for Phase 2.</a:t>
             </a:r>
             <a:endParaRPr lang="en-US" sz="1200" dirty="0"/>
           </a:p>
@@ -7746,7 +8582,7 @@
                 <a:ea typeface="Arial" pitchFamily="34" charset="-122"/>
                 <a:cs typeface="Arial" pitchFamily="34" charset="-120"/>
               </a:rPr>
-              <a:t>Local &amp; air-gapped</a:t>
+              <a:t>Local-first &amp; policy-compliant</a:t>
             </a:r>
             <a:endParaRPr lang="en-US" sz="1600" dirty="0"/>
           </a:p>
@@ -7792,7 +8628,7 @@
                 <a:ea typeface="Arial" pitchFamily="34" charset="-122"/>
                 <a:cs typeface="Arial" pitchFamily="34" charset="-120"/>
               </a:rPr>
-              <a:t>Everything runs on-premise: embedded ArcadeDB, local embedding model (nomic-embed-text-v1.5) and local reranker (ms-marco-MiniLM)</a:t>
+              <a:t>Retrieval stack runs fully on-premise: embedded ArcadeDB, local embedding model (nomic-embed-text-v1.5) and local reranker (ms-marco-MiniLM)</a:t>
             </a:r>
             <a:endParaRPr lang="en-US" sz="1200" dirty="0"/>
           </a:p>
@@ -7816,7 +8652,7 @@
                 <a:ea typeface="Arial" pitchFamily="34" charset="-122"/>
                 <a:cs typeface="Arial" pitchFamily="34" charset="-120"/>
               </a:rPr>
-              <a:t>No cloud API needed for retrieval — process IP and trade secrets never leave the environment</a:t>
+              <a:t>Zero cloud API calls for search, reranking and graph answers</a:t>
             </a:r>
             <a:endParaRPr lang="en-US" sz="1200" dirty="0"/>
           </a:p>
@@ -7840,7 +8676,7 @@
                 <a:ea typeface="Arial" pitchFamily="34" charset="-122"/>
                 <a:cs typeface="Arial" pitchFamily="34" charset="-120"/>
               </a:rPr>
-              <a:t>Unvetted supplier decks and vendor attachments can be ingested safely (hardened parsers)</a:t>
+              <a:t>Narrative answers are generated only through the company’s official corporate AI (Gemini via LiteAi) — no unapproved external services</a:t>
             </a:r>
             <a:endParaRPr lang="en-US" sz="1200" dirty="0"/>
           </a:p>
@@ -7864,7 +8700,7 @@
                 <a:ea typeface="Arial" pitchFamily="34" charset="-122"/>
                 <a:cs typeface="Arial" pitchFamily="34" charset="-120"/>
               </a:rPr>
-              <a:t>Fits corporate policy for AI usage on proprietary process data</a:t>
+              <a:t>Unvetted supplier decks and vendor attachments can be ingested safely (hardened parsers)</a:t>
             </a:r>
             <a:endParaRPr lang="en-US" sz="1200" dirty="0"/>
           </a:p>
@@ -8294,8 +9130,8 @@
         </p:nvSpPr>
         <p:spPr>
           <a:xfrm>
-            <a:off x="6903720" y="2286000"/>
-            <a:ext cx="4389120" cy="960120"/>
+            <a:off x="6903720" y="2212848"/>
+            <a:ext cx="4389120" cy="841248"/>
           </a:xfrm>
           <a:prstGeom prst="rect">
             <a:avLst/>
@@ -8309,12 +9145,12 @@
           <a:p>
             <a:pPr indent="0" marL="0">
               <a:lnSpc>
-                <a:spcPct val="114000"/>
+                <a:spcPct val="112000"/>
               </a:lnSpc>
               <a:buNone/>
             </a:pPr>
             <a:r>
-              <a:rPr lang="en-US" sz="1200" b="1" dirty="0">
+              <a:rPr lang="en-US" sz="1080" b="1" dirty="0">
                 <a:solidFill>
                   <a:srgbClr val="1B2A35"/>
                 </a:solidFill>
@@ -8327,12 +9163,12 @@
             </a:r>
             <a:pPr indent="0" marL="0">
               <a:lnSpc>
-                <a:spcPct val="114000"/>
+                <a:spcPct val="112000"/>
               </a:lnSpc>
               <a:buNone/>
             </a:pPr>
             <a:r>
-              <a:rPr lang="en-US" sz="1200" dirty="0">
+              <a:rPr lang="en-US" sz="1080" dirty="0">
                 <a:solidFill>
                   <a:srgbClr val="3A4A55"/>
                 </a:solidFill>
@@ -8340,9 +9176,9 @@
                 <a:ea typeface="Arial" pitchFamily="34" charset="-122"/>
                 <a:cs typeface="Arial" pitchFamily="34" charset="-120"/>
               </a:rPr>
-              <a:t>Validated process flow accuracy, RACI role mappings and sequence correctness.</a:t>
-            </a:r>
-            <a:endParaRPr lang="en-US" sz="1200" dirty="0"/>
+              <a:t>7 incremental test sessions: Signavio export → retrieval, Dictionary Index, process documents.</a:t>
+            </a:r>
+            <a:endParaRPr lang="en-US" sz="1080" dirty="0"/>
           </a:p>
         </p:txBody>
       </p:sp>
@@ -8354,8 +9190,8 @@
         </p:nvSpPr>
         <p:spPr>
           <a:xfrm>
-            <a:off x="6903720" y="3291840"/>
-            <a:ext cx="4389120" cy="1188720"/>
+            <a:off x="6903720" y="3127248"/>
+            <a:ext cx="4389120" cy="685800"/>
           </a:xfrm>
           <a:prstGeom prst="rect">
             <a:avLst/>
@@ -8369,12 +9205,12 @@
           <a:p>
             <a:pPr indent="0" marL="0">
               <a:lnSpc>
-                <a:spcPct val="114000"/>
+                <a:spcPct val="112000"/>
               </a:lnSpc>
               <a:buNone/>
             </a:pPr>
             <a:r>
-              <a:rPr lang="en-US" sz="1200" b="1" dirty="0">
+              <a:rPr lang="en-US" sz="1080" b="1" dirty="0">
                 <a:solidFill>
                   <a:srgbClr val="1B2A35"/>
                 </a:solidFill>
@@ -8387,12 +9223,12 @@
             </a:r>
             <a:pPr indent="0" marL="0">
               <a:lnSpc>
-                <a:spcPct val="114000"/>
+                <a:spcPct val="112000"/>
               </a:lnSpc>
               <a:buNone/>
             </a:pPr>
             <a:r>
-              <a:rPr lang="en-US" sz="1200" dirty="0">
+              <a:rPr lang="en-US" sz="1080" dirty="0">
                 <a:solidFill>
                   <a:srgbClr val="3A4A55"/>
                 </a:solidFill>
@@ -8400,15 +9236,75 @@
                 <a:ea typeface="Arial" pitchFamily="34" charset="-122"/>
                 <a:cs typeface="Arial" pitchFamily="34" charset="-120"/>
               </a:rPr>
-              <a:t>Validated architectural traceability between SWE.1 requirements, SWE.2 design paths and the underlying specification decks.</a:t>
-            </a:r>
-            <a:endParaRPr lang="en-US" sz="1200" dirty="0"/>
-          </a:p>
-        </p:txBody>
-      </p:sp>
-      <p:sp>
-        <p:nvSpPr>
-          <p:cNvPr id="14" name="Shape 10"/>
+              <a:t>Spot-checked architectural traceability (SWE.1 ↔ SWE.2 ↔ spec decks).</a:t>
+            </a:r>
+            <a:endParaRPr lang="en-US" sz="1080" dirty="0"/>
+          </a:p>
+        </p:txBody>
+      </p:sp>
+      <p:sp>
+        <p:nvSpPr>
+          <p:cNvPr id="14" name="Text 10"/>
+          <p:cNvSpPr txBox="1"/>
+          <p:nvPr/>
+        </p:nvSpPr>
+        <p:spPr>
+          <a:xfrm>
+            <a:off x="6903720" y="3877056"/>
+            <a:ext cx="4389120" cy="594360"/>
+          </a:xfrm>
+          <a:prstGeom prst="rect">
+            <a:avLst/>
+          </a:prstGeom>
+          <a:noFill/>
+          <a:ln/>
+        </p:spPr>
+        <p:txBody>
+          <a:bodyPr wrap="square" lIns="0" tIns="0" rIns="0" bIns="0" rtlCol="0" anchor="ctr"/>
+          <a:lstStyle/>
+          <a:p>
+            <a:pPr indent="0" marL="0">
+              <a:lnSpc>
+                <a:spcPct val="112000"/>
+              </a:lnSpc>
+              <a:buNone/>
+            </a:pPr>
+            <a:r>
+              <a:rPr lang="en-US" sz="1080" b="1" dirty="0">
+                <a:solidFill>
+                  <a:srgbClr val="1B2A35"/>
+                </a:solidFill>
+                <a:latin typeface="Arial" pitchFamily="34" charset="0"/>
+                <a:ea typeface="Arial" pitchFamily="34" charset="-122"/>
+                <a:cs typeface="Arial" pitchFamily="34" charset="-120"/>
+              </a:rPr>
+              <a:t>Abdelrahman Abbas
+</a:t>
+            </a:r>
+            <a:pPr indent="0" marL="0">
+              <a:lnSpc>
+                <a:spcPct val="112000"/>
+              </a:lnSpc>
+              <a:buNone/>
+            </a:pPr>
+            <a:r>
+              <a:rPr lang="en-US" sz="1080" dirty="0">
+                <a:solidFill>
+                  <a:srgbClr val="3A4A55"/>
+                </a:solidFill>
+                <a:latin typeface="Arial" pitchFamily="34" charset="0"/>
+                <a:ea typeface="Arial" pitchFamily="34" charset="-122"/>
+                <a:cs typeface="Arial" pitchFamily="34" charset="-120"/>
+              </a:rPr>
+              <a:t>Independent checks on process Q&amp;A accuracy.</a:t>
+            </a:r>
+            <a:endParaRPr lang="en-US" sz="1080" dirty="0"/>
+          </a:p>
+        </p:txBody>
+      </p:sp>
+      <p:sp>
+        <p:nvSpPr>
+          <p:cNvPr id="15" name="Shape 11"/>
           <p:cNvSpPr/>
           <p:nvPr/>
         </p:nvSpPr>
@@ -8431,7 +9327,7 @@
       </p:sp>
       <p:sp>
         <p:nvSpPr>
-          <p:cNvPr id="15" name="Text 11"/>
+          <p:cNvPr id="16" name="Text 12"/>
           <p:cNvSpPr txBox="1"/>
           <p:nvPr/>
         </p:nvSpPr>
@@ -8465,7 +9361,7 @@
                 <a:ea typeface="Arial" pitchFamily="34" charset="-122"/>
                 <a:cs typeface="Arial" pitchFamily="34" charset="-120"/>
               </a:rPr>
-              <a:t>Frictionless install: </a:t>
+              <a:t>Turnkey deployment: </a:t>
             </a:r>
             <a:pPr indent="0" marL="0">
               <a:lnSpc>
@@ -8482,7 +9378,7 @@
                 <a:ea typeface="Arial" pitchFamily="34" charset="-122"/>
                 <a:cs typeface="Arial" pitchFamily="34" charset="-120"/>
               </a:rPr>
-              <a:t>credentials only — no manual library setup or configuration.</a:t>
+              <a:t>models &amp; embedded DB pre-bundled — the user only enters credentials.</a:t>
             </a:r>
             <a:endParaRPr lang="en-US" sz="1150" dirty="0"/>
           </a:p>
@@ -8490,7 +9386,7 @@
       </p:sp>
       <p:sp>
         <p:nvSpPr>
-          <p:cNvPr id="16" name="Shape 12"/>
+          <p:cNvPr id="17" name="Shape 13"/>
           <p:cNvSpPr/>
           <p:nvPr/>
         </p:nvSpPr>
@@ -8512,7 +9408,7 @@
       </p:sp>
       <p:sp>
         <p:nvSpPr>
-          <p:cNvPr id="17" name="Text 13"/>
+          <p:cNvPr id="18" name="Text 14"/>
           <p:cNvSpPr txBox="1"/>
           <p:nvPr/>
         </p:nvSpPr>
@@ -8546,7 +9442,7 @@
                 <a:ea typeface="Arial" pitchFamily="34" charset="-122"/>
                 <a:cs typeface="Arial" pitchFamily="34" charset="-120"/>
               </a:rPr>
-              <a:t>≈70–80% less  </a:t>
+              <a:t>97.8%  </a:t>
             </a:r>
             <a:pPr indent="0" marL="0">
               <a:lnSpc>
@@ -8563,7 +9459,7 @@
                 <a:ea typeface="Arial" pitchFamily="34" charset="-122"/>
                 <a:cs typeface="Arial" pitchFamily="34" charset="-120"/>
               </a:rPr>
-              <a:t>audit-preparation effort (estimated)*</a:t>
+              <a:t>retrieval accuracy on the development eval — incl. needle-in-haystack &amp; multi-hop questions*</a:t>
             </a:r>
             <a:endParaRPr lang="en-US" sz="1500" dirty="0"/>
           </a:p>
@@ -8571,7 +9467,7 @@
       </p:sp>
       <p:sp>
         <p:nvSpPr>
-          <p:cNvPr id="18" name="Shape 14"/>
+          <p:cNvPr id="19" name="Shape 15"/>
           <p:cNvSpPr/>
           <p:nvPr/>
         </p:nvSpPr>
@@ -8593,7 +9489,7 @@
       </p:sp>
       <p:sp>
         <p:nvSpPr>
-          <p:cNvPr id="19" name="Text 15"/>
+          <p:cNvPr id="20" name="Text 16"/>
           <p:cNvSpPr txBox="1"/>
           <p:nvPr/>
         </p:nvSpPr>
@@ -8652,7 +9548,7 @@
       </p:sp>
       <p:sp>
         <p:nvSpPr>
-          <p:cNvPr id="20" name="Text 16"/>
+          <p:cNvPr id="21" name="Text 17"/>
           <p:cNvSpPr txBox="1"/>
           <p:nvPr/>
         </p:nvSpPr>
@@ -8683,7 +9579,7 @@
                 <a:ea typeface="Arial" pitchFamily="34" charset="-122"/>
                 <a:cs typeface="Arial" pitchFamily="34" charset="-120"/>
               </a:rPr>
-              <a:t>* Internal estimates from pilot usage — to be confirmed with measured data during rollout.</a:t>
+              <a:t>* Accuracy from an automated (AI-judged) evaluation — 20 generated questions per document; time savings are internal estimates. Both to be re-measured during rollout.</a:t>
             </a:r>
             <a:endParaRPr lang="en-US" sz="950" dirty="0"/>
           </a:p>
@@ -8691,7 +9587,7 @@
       </p:sp>
       <p:sp>
         <p:nvSpPr>
-          <p:cNvPr id="21" name="Text 17"/>
+          <p:cNvPr id="22" name="Text 18"/>
           <p:cNvSpPr txBox="1"/>
           <p:nvPr/>
         </p:nvSpPr>
@@ -8819,7 +9715,7 @@
                 <a:gridCol w="3840480"/>
                 <a:gridCol w="4416552"/>
               </a:tblGrid>
-              <a:tr h="566928">
+              <a:tr h="512064">
                 <a:tc>
                   <a:txBody>
                     <a:bodyPr/>
@@ -9025,7 +9921,7 @@
                   </a:tcPr>
                 </a:tc>
               </a:tr>
-              <a:tr h="566928">
+              <a:tr h="512064">
                 <a:tc>
                   <a:txBody>
                     <a:bodyPr/>
@@ -9035,7 +9931,7 @@
                         <a:buNone/>
                       </a:pPr>
                       <a:r>
-                        <a:rPr lang="en-US" sz="1150" b="1" dirty="0">
+                        <a:rPr lang="en-US" sz="1100" b="1" dirty="0">
                           <a:solidFill>
                             <a:srgbClr val="3A4A55"/>
                           </a:solidFill>
@@ -9045,7 +9941,7 @@
                         </a:rPr>
                         <a:t>BPMN / Signavio models</a:t>
                       </a:r>
-                      <a:endParaRPr lang="en-US" sz="1150" dirty="0">
+                      <a:endParaRPr lang="en-US" sz="1100" dirty="0">
                         <a:latin typeface="Arial" charset="0"/>
                         <a:ea typeface="Arial" charset="0"/>
                         <a:cs typeface="Arial" charset="0"/>
@@ -9100,7 +9996,7 @@
                         <a:buNone/>
                       </a:pPr>
                       <a:r>
-                        <a:rPr lang="en-US" sz="1150" b="1" dirty="0">
+                        <a:rPr lang="en-US" sz="1100" b="1" dirty="0">
                           <a:solidFill>
                             <a:srgbClr val="C0392B"/>
                           </a:solidFill>
@@ -9114,7 +10010,7 @@
                         <a:buNone/>
                       </a:pPr>
                       <a:r>
-                        <a:rPr lang="en-US" sz="1150" dirty="0">
+                        <a:rPr lang="en-US" sz="1100" dirty="0">
                           <a:solidFill>
                             <a:srgbClr val="3A4A55"/>
                           </a:solidFill>
@@ -9124,7 +10020,7 @@
                         </a:rPr>
                         <a:t>Flat text conversion only</a:t>
                       </a:r>
-                      <a:endParaRPr lang="en-US" sz="1150" dirty="0">
+                      <a:endParaRPr lang="en-US" sz="1100" dirty="0">
                         <a:latin typeface="Arial" charset="0"/>
                         <a:ea typeface="Arial" charset="0"/>
                         <a:cs typeface="Arial" charset="0"/>
@@ -9179,7 +10075,7 @@
                         <a:buNone/>
                       </a:pPr>
                       <a:r>
-                        <a:rPr lang="en-US" sz="1150" b="1" dirty="0">
+                        <a:rPr lang="en-US" sz="1100" b="1" dirty="0">
                           <a:solidFill>
                             <a:srgbClr val="028090"/>
                           </a:solidFill>
@@ -9193,7 +10089,7 @@
                         <a:buNone/>
                       </a:pPr>
                       <a:r>
-                        <a:rPr lang="en-US" sz="1150" dirty="0">
+                        <a:rPr lang="en-US" sz="1100" dirty="0">
                           <a:solidFill>
                             <a:srgbClr val="1B2A35"/>
                           </a:solidFill>
@@ -9203,7 +10099,7 @@
                         </a:rPr>
                         <a:t>Native graph + live MCP sync &amp; diff</a:t>
                       </a:r>
-                      <a:endParaRPr lang="en-US" sz="1150" dirty="0">
+                      <a:endParaRPr lang="en-US" sz="1100" dirty="0">
                         <a:latin typeface="Arial" charset="0"/>
                         <a:ea typeface="Arial" charset="0"/>
                         <a:cs typeface="Arial" charset="0"/>
@@ -9250,7 +10146,7 @@
                   </a:tcPr>
                 </a:tc>
               </a:tr>
-              <a:tr h="566928">
+              <a:tr h="512064">
                 <a:tc>
                   <a:txBody>
                     <a:bodyPr/>
@@ -9260,7 +10156,7 @@
                         <a:buNone/>
                       </a:pPr>
                       <a:r>
-                        <a:rPr lang="en-US" sz="1150" b="1" dirty="0">
+                        <a:rPr lang="en-US" sz="1100" b="1" dirty="0">
                           <a:solidFill>
                             <a:srgbClr val="3A4A55"/>
                           </a:solidFill>
@@ -9270,7 +10166,7 @@
                         </a:rPr>
                         <a:t>Step order &amp; RACI</a:t>
                       </a:r>
-                      <a:endParaRPr lang="en-US" sz="1150" dirty="0">
+                      <a:endParaRPr lang="en-US" sz="1100" dirty="0">
                         <a:latin typeface="Arial" charset="0"/>
                         <a:ea typeface="Arial" charset="0"/>
                         <a:cs typeface="Arial" charset="0"/>
@@ -9325,7 +10221,7 @@
                         <a:buNone/>
                       </a:pPr>
                       <a:r>
-                        <a:rPr lang="en-US" sz="1150" b="1" dirty="0">
+                        <a:rPr lang="en-US" sz="1100" b="1" dirty="0">
                           <a:solidFill>
                             <a:srgbClr val="C77700"/>
                           </a:solidFill>
@@ -9339,7 +10235,7 @@
                         <a:buNone/>
                       </a:pPr>
                       <a:r>
-                        <a:rPr lang="en-US" sz="1150" dirty="0">
+                        <a:rPr lang="en-US" sz="1100" dirty="0">
                           <a:solidFill>
                             <a:srgbClr val="3A4A55"/>
                           </a:solidFill>
@@ -9349,7 +10245,7 @@
                         </a:rPr>
                         <a:t>hallucination-prone</a:t>
                       </a:r>
-                      <a:endParaRPr lang="en-US" sz="1150" dirty="0">
+                      <a:endParaRPr lang="en-US" sz="1100" dirty="0">
                         <a:latin typeface="Arial" charset="0"/>
                         <a:ea typeface="Arial" charset="0"/>
                         <a:cs typeface="Arial" charset="0"/>
@@ -9404,7 +10300,7 @@
                         <a:buNone/>
                       </a:pPr>
                       <a:r>
-                        <a:rPr lang="en-US" sz="1150" b="1" dirty="0">
+                        <a:rPr lang="en-US" sz="1100" b="1" dirty="0">
                           <a:solidFill>
                             <a:srgbClr val="028090"/>
                           </a:solidFill>
@@ -9418,7 +10314,7 @@
                         <a:buNone/>
                       </a:pPr>
                       <a:r>
-                        <a:rPr lang="en-US" sz="1150" dirty="0">
+                        <a:rPr lang="en-US" sz="1100" dirty="0">
                           <a:solidFill>
                             <a:srgbClr val="1B2A35"/>
                           </a:solidFill>
@@ -9428,7 +10324,7 @@
                         </a:rPr>
                         <a:t>100% deterministic graph queries</a:t>
                       </a:r>
-                      <a:endParaRPr lang="en-US" sz="1150" dirty="0">
+                      <a:endParaRPr lang="en-US" sz="1100" dirty="0">
                         <a:latin typeface="Arial" charset="0"/>
                         <a:ea typeface="Arial" charset="0"/>
                         <a:cs typeface="Arial" charset="0"/>
@@ -9475,7 +10371,7 @@
                   </a:tcPr>
                 </a:tc>
               </a:tr>
-              <a:tr h="566928">
+              <a:tr h="512064">
                 <a:tc>
                   <a:txBody>
                     <a:bodyPr/>
@@ -9485,7 +10381,7 @@
                         <a:buNone/>
                       </a:pPr>
                       <a:r>
-                        <a:rPr lang="en-US" sz="1150" b="1" dirty="0">
+                        <a:rPr lang="en-US" sz="1100" b="1" dirty="0">
                           <a:solidFill>
                             <a:srgbClr val="3A4A55"/>
                           </a:solidFill>
@@ -9495,7 +10391,7 @@
                         </a:rPr>
                         <a:t>SmartArt &amp; cached charts</a:t>
                       </a:r>
-                      <a:endParaRPr lang="en-US" sz="1150" dirty="0">
+                      <a:endParaRPr lang="en-US" sz="1100" dirty="0">
                         <a:latin typeface="Arial" charset="0"/>
                         <a:ea typeface="Arial" charset="0"/>
                         <a:cs typeface="Arial" charset="0"/>
@@ -9550,7 +10446,7 @@
                         <a:buNone/>
                       </a:pPr>
                       <a:r>
-                        <a:rPr lang="en-US" sz="1150" b="1" dirty="0">
+                        <a:rPr lang="en-US" sz="1100" b="1" dirty="0">
                           <a:solidFill>
                             <a:srgbClr val="C0392B"/>
                           </a:solidFill>
@@ -9564,7 +10460,7 @@
                         <a:buNone/>
                       </a:pPr>
                       <a:r>
-                        <a:rPr lang="en-US" sz="1150" dirty="0">
+                        <a:rPr lang="en-US" sz="1100" dirty="0">
                           <a:solidFill>
                             <a:srgbClr val="3A4A55"/>
                           </a:solidFill>
@@ -9574,7 +10470,7 @@
                         </a:rPr>
                         <a:t>Skipped</a:t>
                       </a:r>
-                      <a:endParaRPr lang="en-US" sz="1150" dirty="0">
+                      <a:endParaRPr lang="en-US" sz="1100" dirty="0">
                         <a:latin typeface="Arial" charset="0"/>
                         <a:ea typeface="Arial" charset="0"/>
                         <a:cs typeface="Arial" charset="0"/>
@@ -9629,7 +10525,7 @@
                         <a:buNone/>
                       </a:pPr>
                       <a:r>
-                        <a:rPr lang="en-US" sz="1150" b="1" dirty="0">
+                        <a:rPr lang="en-US" sz="1100" b="1" dirty="0">
                           <a:solidFill>
                             <a:srgbClr val="028090"/>
                           </a:solidFill>
@@ -9643,7 +10539,7 @@
                         <a:buNone/>
                       </a:pPr>
                       <a:r>
-                        <a:rPr lang="en-US" sz="1150" dirty="0">
+                        <a:rPr lang="en-US" sz="1100" dirty="0">
                           <a:solidFill>
                             <a:srgbClr val="1B2A35"/>
                           </a:solidFill>
@@ -9653,7 +10549,7 @@
                         </a:rPr>
                         <a:t>Extracted via direct OOXML parsing</a:t>
                       </a:r>
-                      <a:endParaRPr lang="en-US" sz="1150" dirty="0">
+                      <a:endParaRPr lang="en-US" sz="1100" dirty="0">
                         <a:latin typeface="Arial" charset="0"/>
                         <a:ea typeface="Arial" charset="0"/>
                         <a:cs typeface="Arial" charset="0"/>
@@ -9700,7 +10596,7 @@
                   </a:tcPr>
                 </a:tc>
               </a:tr>
-              <a:tr h="566928">
+              <a:tr h="512064">
                 <a:tc>
                   <a:txBody>
                     <a:bodyPr/>
@@ -9710,7 +10606,7 @@
                         <a:buNone/>
                       </a:pPr>
                       <a:r>
-                        <a:rPr lang="en-US" sz="1150" b="1" dirty="0">
+                        <a:rPr lang="en-US" sz="1100" b="1" dirty="0">
                           <a:solidFill>
                             <a:srgbClr val="3A4A55"/>
                           </a:solidFill>
@@ -9720,7 +10616,7 @@
                         </a:rPr>
                         <a:t>Embedded Excel / Word / PDF</a:t>
                       </a:r>
-                      <a:endParaRPr lang="en-US" sz="1150" dirty="0">
+                      <a:endParaRPr lang="en-US" sz="1100" dirty="0">
                         <a:latin typeface="Arial" charset="0"/>
                         <a:ea typeface="Arial" charset="0"/>
                         <a:cs typeface="Arial" charset="0"/>
@@ -9775,7 +10671,7 @@
                         <a:buNone/>
                       </a:pPr>
                       <a:r>
-                        <a:rPr lang="en-US" sz="1150" b="1" dirty="0">
+                        <a:rPr lang="en-US" sz="1100" b="1" dirty="0">
                           <a:solidFill>
                             <a:srgbClr val="C0392B"/>
                           </a:solidFill>
@@ -9789,7 +10685,7 @@
                         <a:buNone/>
                       </a:pPr>
                       <a:r>
-                        <a:rPr lang="en-US" sz="1150" dirty="0">
+                        <a:rPr lang="en-US" sz="1100" dirty="0">
                           <a:solidFill>
                             <a:srgbClr val="3A4A55"/>
                           </a:solidFill>
@@ -9799,7 +10695,7 @@
                         </a:rPr>
                         <a:t>Ignored</a:t>
                       </a:r>
-                      <a:endParaRPr lang="en-US" sz="1150" dirty="0">
+                      <a:endParaRPr lang="en-US" sz="1100" dirty="0">
                         <a:latin typeface="Arial" charset="0"/>
                         <a:ea typeface="Arial" charset="0"/>
                         <a:cs typeface="Arial" charset="0"/>
@@ -9854,7 +10750,7 @@
                         <a:buNone/>
                       </a:pPr>
                       <a:r>
-                        <a:rPr lang="en-US" sz="1150" b="1" dirty="0">
+                        <a:rPr lang="en-US" sz="1100" b="1" dirty="0">
                           <a:solidFill>
                             <a:srgbClr val="028090"/>
                           </a:solidFill>
@@ -9868,7 +10764,7 @@
                         <a:buNone/>
                       </a:pPr>
                       <a:r>
-                        <a:rPr lang="en-US" sz="1150" dirty="0">
+                        <a:rPr lang="en-US" sz="1100" dirty="0">
                           <a:solidFill>
                             <a:srgbClr val="1B2A35"/>
                           </a:solidFill>
@@ -9876,9 +10772,9 @@
                           <a:ea typeface="Arial" pitchFamily="34" charset="-122"/>
                           <a:cs typeface="Arial" pitchFamily="34" charset="-120"/>
                         </a:rPr>
-                        <a:t>Extracted &amp; indexed (AssetStore)</a:t>
+                        <a:t>Isolated &amp; position-stamped — content parsing: Phase 2</a:t>
                       </a:r>
-                      <a:endParaRPr lang="en-US" sz="1150" dirty="0">
+                      <a:endParaRPr lang="en-US" sz="1100" dirty="0">
                         <a:latin typeface="Arial" charset="0"/>
                         <a:ea typeface="Arial" charset="0"/>
                         <a:cs typeface="Arial" charset="0"/>
@@ -9925,7 +10821,7 @@
                   </a:tcPr>
                 </a:tc>
               </a:tr>
-              <a:tr h="566928">
+              <a:tr h="512064">
                 <a:tc>
                   <a:txBody>
                     <a:bodyPr/>
@@ -9935,7 +10831,7 @@
                         <a:buNone/>
                       </a:pPr>
                       <a:r>
-                        <a:rPr lang="en-US" sz="1150" b="1" dirty="0">
+                        <a:rPr lang="en-US" sz="1100" b="1" dirty="0">
                           <a:solidFill>
                             <a:srgbClr val="3A4A55"/>
                           </a:solidFill>
@@ -9945,7 +10841,7 @@
                         </a:rPr>
                         <a:t>Requirement IDs (UIDs)</a:t>
                       </a:r>
-                      <a:endParaRPr lang="en-US" sz="1150" dirty="0">
+                      <a:endParaRPr lang="en-US" sz="1100" dirty="0">
                         <a:latin typeface="Arial" charset="0"/>
                         <a:ea typeface="Arial" charset="0"/>
                         <a:cs typeface="Arial" charset="0"/>
@@ -10000,7 +10896,7 @@
                         <a:buNone/>
                       </a:pPr>
                       <a:r>
-                        <a:rPr lang="en-US" sz="1150" b="1" dirty="0">
+                        <a:rPr lang="en-US" sz="1100" b="1" dirty="0">
                           <a:solidFill>
                             <a:srgbClr val="C0392B"/>
                           </a:solidFill>
@@ -10014,7 +10910,7 @@
                         <a:buNone/>
                       </a:pPr>
                       <a:r>
-                        <a:rPr lang="en-US" sz="1150" dirty="0">
+                        <a:rPr lang="en-US" sz="1100" dirty="0">
                           <a:solidFill>
                             <a:srgbClr val="3A4A55"/>
                           </a:solidFill>
@@ -10024,7 +10920,7 @@
                         </a:rPr>
                         <a:t>Shredded by the tokenizer</a:t>
                       </a:r>
-                      <a:endParaRPr lang="en-US" sz="1150" dirty="0">
+                      <a:endParaRPr lang="en-US" sz="1100" dirty="0">
                         <a:latin typeface="Arial" charset="0"/>
                         <a:ea typeface="Arial" charset="0"/>
                         <a:cs typeface="Arial" charset="0"/>
@@ -10079,7 +10975,7 @@
                         <a:buNone/>
                       </a:pPr>
                       <a:r>
-                        <a:rPr lang="en-US" sz="1150" b="1" dirty="0">
+                        <a:rPr lang="en-US" sz="1100" b="1" dirty="0">
                           <a:solidFill>
                             <a:srgbClr val="028090"/>
                           </a:solidFill>
@@ -10093,7 +10989,7 @@
                         <a:buNone/>
                       </a:pPr>
                       <a:r>
-                        <a:rPr lang="en-US" sz="1150" dirty="0">
+                        <a:rPr lang="en-US" sz="1100" dirty="0">
                           <a:solidFill>
                             <a:srgbClr val="1B2A35"/>
                           </a:solidFill>
@@ -10101,9 +10997,9 @@
                           <a:ea typeface="Arial" pitchFamily="34" charset="-122"/>
                           <a:cs typeface="Arial" pitchFamily="34" charset="-120"/>
                         </a:rPr>
-                        <a:t>Canonical index + exact trace edges</a:t>
+                        <a:t>Canonical index + automated trace graphs (DERIVE / VERIFY / SATISFY)</a:t>
                       </a:r>
-                      <a:endParaRPr lang="en-US" sz="1150" dirty="0">
+                      <a:endParaRPr lang="en-US" sz="1100" dirty="0">
                         <a:latin typeface="Arial" charset="0"/>
                         <a:ea typeface="Arial" charset="0"/>
                         <a:cs typeface="Arial" charset="0"/>
@@ -10150,7 +11046,7 @@
                   </a:tcPr>
                 </a:tc>
               </a:tr>
-              <a:tr h="566928">
+              <a:tr h="512064">
                 <a:tc>
                   <a:txBody>
                     <a:bodyPr/>
@@ -10160,7 +11056,7 @@
                         <a:buNone/>
                       </a:pPr>
                       <a:r>
-                        <a:rPr lang="en-US" sz="1150" b="1" dirty="0">
+                        <a:rPr lang="en-US" sz="1100" b="1" dirty="0">
                           <a:solidFill>
                             <a:srgbClr val="3A4A55"/>
                           </a:solidFill>
@@ -10168,9 +11064,9 @@
                           <a:ea typeface="Arial" pitchFamily="34" charset="-122"/>
                           <a:cs typeface="Arial" pitchFamily="34" charset="-120"/>
                         </a:rPr>
-                        <a:t>Citations</a:t>
+                        <a:t>Security &amp; parsing resilience</a:t>
                       </a:r>
-                      <a:endParaRPr lang="en-US" sz="1150" dirty="0">
+                      <a:endParaRPr lang="en-US" sz="1100" dirty="0">
                         <a:latin typeface="Arial" charset="0"/>
                         <a:ea typeface="Arial" charset="0"/>
                         <a:cs typeface="Arial" charset="0"/>
@@ -10225,7 +11121,7 @@
                         <a:buNone/>
                       </a:pPr>
                       <a:r>
-                        <a:rPr lang="en-US" sz="1150" b="1" dirty="0">
+                        <a:rPr lang="en-US" sz="1100" b="1" dirty="0">
                           <a:solidFill>
                             <a:srgbClr val="C0392B"/>
                           </a:solidFill>
@@ -10239,7 +11135,7 @@
                         <a:buNone/>
                       </a:pPr>
                       <a:r>
-                        <a:rPr lang="en-US" sz="1150" dirty="0">
+                        <a:rPr lang="en-US" sz="1100" dirty="0">
                           <a:solidFill>
                             <a:srgbClr val="3A4A55"/>
                           </a:solidFill>
@@ -10247,9 +11143,9 @@
                           <a:ea typeface="Arial" pitchFamily="34" charset="-122"/>
                           <a:cs typeface="Arial" pitchFamily="34" charset="-120"/>
                         </a:rPr>
-                        <a:t>Best-effort, unverified</a:t>
+                        <a:t>Vulnerable to XXE / zip-bombs</a:t>
                       </a:r>
-                      <a:endParaRPr lang="en-US" sz="1150" dirty="0">
+                      <a:endParaRPr lang="en-US" sz="1100" dirty="0">
                         <a:latin typeface="Arial" charset="0"/>
                         <a:ea typeface="Arial" charset="0"/>
                         <a:cs typeface="Arial" charset="0"/>
@@ -10304,7 +11200,7 @@
                         <a:buNone/>
                       </a:pPr>
                       <a:r>
-                        <a:rPr lang="en-US" sz="1150" b="1" dirty="0">
+                        <a:rPr lang="en-US" sz="1100" b="1" dirty="0">
                           <a:solidFill>
                             <a:srgbClr val="028090"/>
                           </a:solidFill>
@@ -10318,7 +11214,7 @@
                         <a:buNone/>
                       </a:pPr>
                       <a:r>
-                        <a:rPr lang="en-US" sz="1150" dirty="0">
+                        <a:rPr lang="en-US" sz="1100" dirty="0">
                           <a:solidFill>
                             <a:srgbClr val="1B2A35"/>
                           </a:solidFill>
@@ -10326,9 +11222,9 @@
                           <a:ea typeface="Arial" pitchFamily="34" charset="-122"/>
                           <a:cs typeface="Arial" pitchFamily="34" charset="-120"/>
                         </a:rPr>
-                        <a:t>Exact file · slide · section, pre-stamped</a:t>
+                        <a:t>Hardened XML security + process-pool locks</a:t>
                       </a:r>
-                      <a:endParaRPr lang="en-US" sz="1150" dirty="0">
+                      <a:endParaRPr lang="en-US" sz="1100" dirty="0">
                         <a:latin typeface="Arial" charset="0"/>
                         <a:ea typeface="Arial" charset="0"/>
                         <a:cs typeface="Arial" charset="0"/>
@@ -10375,7 +11271,7 @@
                   </a:tcPr>
                 </a:tc>
               </a:tr>
-              <a:tr h="566928">
+              <a:tr h="512064">
                 <a:tc>
                   <a:txBody>
                     <a:bodyPr/>
@@ -10385,7 +11281,7 @@
                         <a:buNone/>
                       </a:pPr>
                       <a:r>
-                        <a:rPr lang="en-US" sz="1150" b="1" dirty="0">
+                        <a:rPr lang="en-US" sz="1100" b="1" dirty="0">
                           <a:solidFill>
                             <a:srgbClr val="3A4A55"/>
                           </a:solidFill>
@@ -10393,9 +11289,9 @@
                           <a:ea typeface="Arial" pitchFamily="34" charset="-122"/>
                           <a:cs typeface="Arial" pitchFamily="34" charset="-120"/>
                         </a:rPr>
-                        <a:t>Visual output</a:t>
+                        <a:t>Citations</a:t>
                       </a:r>
-                      <a:endParaRPr lang="en-US" sz="1150" dirty="0">
+                      <a:endParaRPr lang="en-US" sz="1100" dirty="0">
                         <a:latin typeface="Arial" charset="0"/>
                         <a:ea typeface="Arial" charset="0"/>
                         <a:cs typeface="Arial" charset="0"/>
@@ -10450,7 +11346,7 @@
                         <a:buNone/>
                       </a:pPr>
                       <a:r>
-                        <a:rPr lang="en-US" sz="1150" b="1" dirty="0">
+                        <a:rPr lang="en-US" sz="1100" b="1" dirty="0">
                           <a:solidFill>
                             <a:srgbClr val="C0392B"/>
                           </a:solidFill>
@@ -10464,7 +11360,7 @@
                         <a:buNone/>
                       </a:pPr>
                       <a:r>
-                        <a:rPr lang="en-US" sz="1150" dirty="0">
+                        <a:rPr lang="en-US" sz="1100" dirty="0">
                           <a:solidFill>
                             <a:srgbClr val="3A4A55"/>
                           </a:solidFill>
@@ -10472,9 +11368,9 @@
                           <a:ea typeface="Arial" pitchFamily="34" charset="-122"/>
                           <a:cs typeface="Arial" pitchFamily="34" charset="-120"/>
                         </a:rPr>
-                        <a:t>Text only</a:t>
+                        <a:t>Best-effort, unverified</a:t>
                       </a:r>
-                      <a:endParaRPr lang="en-US" sz="1150" dirty="0">
+                      <a:endParaRPr lang="en-US" sz="1100" dirty="0">
                         <a:latin typeface="Arial" charset="0"/>
                         <a:ea typeface="Arial" charset="0"/>
                         <a:cs typeface="Arial" charset="0"/>
@@ -10529,7 +11425,7 @@
                         <a:buNone/>
                       </a:pPr>
                       <a:r>
-                        <a:rPr lang="en-US" sz="1150" b="1" dirty="0">
+                        <a:rPr lang="en-US" sz="1100" b="1" dirty="0">
                           <a:solidFill>
                             <a:srgbClr val="028090"/>
                           </a:solidFill>
@@ -10543,7 +11439,232 @@
                         <a:buNone/>
                       </a:pPr>
                       <a:r>
-                        <a:rPr lang="en-US" sz="1150" dirty="0">
+                        <a:rPr lang="en-US" sz="1100" dirty="0">
+                          <a:solidFill>
+                            <a:srgbClr val="1B2A35"/>
+                          </a:solidFill>
+                          <a:latin typeface="Arial" pitchFamily="34" charset="0"/>
+                          <a:ea typeface="Arial" pitchFamily="34" charset="-122"/>
+                          <a:cs typeface="Arial" pitchFamily="34" charset="-120"/>
+                        </a:rPr>
+                        <a:t>Exact file · slide · section, pre-stamped</a:t>
+                      </a:r>
+                      <a:endParaRPr lang="en-US" sz="1100" dirty="0">
+                        <a:latin typeface="Arial" charset="0"/>
+                        <a:ea typeface="Arial" charset="0"/>
+                        <a:cs typeface="Arial" charset="0"/>
+                      </a:endParaRPr>
+                    </a:p>
+                  </a:txBody>
+                  <a:tcPr marL="91440" marR="91440" marT="54864" marB="54864" anchor="ctr">
+                    <a:lnL w="9525" cap="flat" cmpd="sng" algn="ctr">
+                      <a:solidFill>
+                        <a:srgbClr val="D7E0E6"/>
+                      </a:solidFill>
+                      <a:prstDash val="solid"/>
+                      <a:round/>
+                      <a:headEnd type="none" w="med" len="med"/>
+                      <a:tailEnd type="none" w="med" len="med"/>
+                    </a:lnL>
+                    <a:lnR w="9525" cap="flat" cmpd="sng" algn="ctr">
+                      <a:solidFill>
+                        <a:srgbClr val="D7E0E6"/>
+                      </a:solidFill>
+                      <a:prstDash val="solid"/>
+                      <a:round/>
+                      <a:headEnd type="none" w="med" len="med"/>
+                      <a:tailEnd type="none" w="med" len="med"/>
+                    </a:lnR>
+                    <a:lnT w="9525" cap="flat" cmpd="sng" algn="ctr">
+                      <a:solidFill>
+                        <a:srgbClr val="D7E0E6"/>
+                      </a:solidFill>
+                      <a:prstDash val="solid"/>
+                      <a:round/>
+                      <a:headEnd type="none" w="med" len="med"/>
+                      <a:tailEnd type="none" w="med" len="med"/>
+                    </a:lnT>
+                    <a:lnB w="9525" cap="flat" cmpd="sng" algn="ctr">
+                      <a:solidFill>
+                        <a:srgbClr val="D7E0E6"/>
+                      </a:solidFill>
+                      <a:prstDash val="solid"/>
+                      <a:round/>
+                      <a:headEnd type="none" w="med" len="med"/>
+                      <a:tailEnd type="none" w="med" len="med"/>
+                    </a:lnB>
+                  </a:tcPr>
+                </a:tc>
+              </a:tr>
+              <a:tr h="512064">
+                <a:tc>
+                  <a:txBody>
+                    <a:bodyPr/>
+                    <a:lstStyle/>
+                    <a:p>
+                      <a:pPr indent="0" marL="0">
+                        <a:buNone/>
+                      </a:pPr>
+                      <a:r>
+                        <a:rPr lang="en-US" sz="1100" b="1" dirty="0">
+                          <a:solidFill>
+                            <a:srgbClr val="3A4A55"/>
+                          </a:solidFill>
+                          <a:latin typeface="Arial" pitchFamily="34" charset="0"/>
+                          <a:ea typeface="Arial" pitchFamily="34" charset="-122"/>
+                          <a:cs typeface="Arial" pitchFamily="34" charset="-120"/>
+                        </a:rPr>
+                        <a:t>Visual output</a:t>
+                      </a:r>
+                      <a:endParaRPr lang="en-US" sz="1100" dirty="0">
+                        <a:latin typeface="Arial" charset="0"/>
+                        <a:ea typeface="Arial" charset="0"/>
+                        <a:cs typeface="Arial" charset="0"/>
+                      </a:endParaRPr>
+                    </a:p>
+                  </a:txBody>
+                  <a:tcPr marL="91440" marR="91440" marT="54864" marB="54864" anchor="ctr">
+                    <a:lnL w="9525" cap="flat" cmpd="sng" algn="ctr">
+                      <a:solidFill>
+                        <a:srgbClr val="D7E0E6"/>
+                      </a:solidFill>
+                      <a:prstDash val="solid"/>
+                      <a:round/>
+                      <a:headEnd type="none" w="med" len="med"/>
+                      <a:tailEnd type="none" w="med" len="med"/>
+                    </a:lnL>
+                    <a:lnR w="9525" cap="flat" cmpd="sng" algn="ctr">
+                      <a:solidFill>
+                        <a:srgbClr val="D7E0E6"/>
+                      </a:solidFill>
+                      <a:prstDash val="solid"/>
+                      <a:round/>
+                      <a:headEnd type="none" w="med" len="med"/>
+                      <a:tailEnd type="none" w="med" len="med"/>
+                    </a:lnR>
+                    <a:lnT w="9525" cap="flat" cmpd="sng" algn="ctr">
+                      <a:solidFill>
+                        <a:srgbClr val="D7E0E6"/>
+                      </a:solidFill>
+                      <a:prstDash val="solid"/>
+                      <a:round/>
+                      <a:headEnd type="none" w="med" len="med"/>
+                      <a:tailEnd type="none" w="med" len="med"/>
+                    </a:lnT>
+                    <a:lnB w="9525" cap="flat" cmpd="sng" algn="ctr">
+                      <a:solidFill>
+                        <a:srgbClr val="D7E0E6"/>
+                      </a:solidFill>
+                      <a:prstDash val="solid"/>
+                      <a:round/>
+                      <a:headEnd type="none" w="med" len="med"/>
+                      <a:tailEnd type="none" w="med" len="med"/>
+                    </a:lnB>
+                  </a:tcPr>
+                </a:tc>
+                <a:tc>
+                  <a:txBody>
+                    <a:bodyPr/>
+                    <a:lstStyle/>
+                    <a:p>
+                      <a:pPr indent="0" marL="0">
+                        <a:buNone/>
+                      </a:pPr>
+                      <a:r>
+                        <a:rPr lang="en-US" sz="1100" b="1" dirty="0">
+                          <a:solidFill>
+                            <a:srgbClr val="C0392B"/>
+                          </a:solidFill>
+                          <a:latin typeface="Arial" pitchFamily="34" charset="0"/>
+                          <a:ea typeface="Arial" pitchFamily="34" charset="-122"/>
+                          <a:cs typeface="Arial" pitchFamily="34" charset="-120"/>
+                        </a:rPr>
+                        <a:t>✗  </a:t>
+                      </a:r>
+                      <a:pPr indent="0" marL="0">
+                        <a:buNone/>
+                      </a:pPr>
+                      <a:r>
+                        <a:rPr lang="en-US" sz="1100" dirty="0">
+                          <a:solidFill>
+                            <a:srgbClr val="3A4A55"/>
+                          </a:solidFill>
+                          <a:latin typeface="Arial" pitchFamily="34" charset="0"/>
+                          <a:ea typeface="Arial" pitchFamily="34" charset="-122"/>
+                          <a:cs typeface="Arial" pitchFamily="34" charset="-120"/>
+                        </a:rPr>
+                        <a:t>Text only</a:t>
+                      </a:r>
+                      <a:endParaRPr lang="en-US" sz="1100" dirty="0">
+                        <a:latin typeface="Arial" charset="0"/>
+                        <a:ea typeface="Arial" charset="0"/>
+                        <a:cs typeface="Arial" charset="0"/>
+                      </a:endParaRPr>
+                    </a:p>
+                  </a:txBody>
+                  <a:tcPr marL="91440" marR="91440" marT="54864" marB="54864" anchor="ctr">
+                    <a:lnL w="9525" cap="flat" cmpd="sng" algn="ctr">
+                      <a:solidFill>
+                        <a:srgbClr val="D7E0E6"/>
+                      </a:solidFill>
+                      <a:prstDash val="solid"/>
+                      <a:round/>
+                      <a:headEnd type="none" w="med" len="med"/>
+                      <a:tailEnd type="none" w="med" len="med"/>
+                    </a:lnL>
+                    <a:lnR w="9525" cap="flat" cmpd="sng" algn="ctr">
+                      <a:solidFill>
+                        <a:srgbClr val="D7E0E6"/>
+                      </a:solidFill>
+                      <a:prstDash val="solid"/>
+                      <a:round/>
+                      <a:headEnd type="none" w="med" len="med"/>
+                      <a:tailEnd type="none" w="med" len="med"/>
+                    </a:lnR>
+                    <a:lnT w="9525" cap="flat" cmpd="sng" algn="ctr">
+                      <a:solidFill>
+                        <a:srgbClr val="D7E0E6"/>
+                      </a:solidFill>
+                      <a:prstDash val="solid"/>
+                      <a:round/>
+                      <a:headEnd type="none" w="med" len="med"/>
+                      <a:tailEnd type="none" w="med" len="med"/>
+                    </a:lnT>
+                    <a:lnB w="9525" cap="flat" cmpd="sng" algn="ctr">
+                      <a:solidFill>
+                        <a:srgbClr val="D7E0E6"/>
+                      </a:solidFill>
+                      <a:prstDash val="solid"/>
+                      <a:round/>
+                      <a:headEnd type="none" w="med" len="med"/>
+                      <a:tailEnd type="none" w="med" len="med"/>
+                    </a:lnB>
+                  </a:tcPr>
+                </a:tc>
+                <a:tc>
+                  <a:txBody>
+                    <a:bodyPr/>
+                    <a:lstStyle/>
+                    <a:p>
+                      <a:pPr indent="0" marL="0">
+                        <a:buNone/>
+                      </a:pPr>
+                      <a:r>
+                        <a:rPr lang="en-US" sz="1100" b="1" dirty="0">
+                          <a:solidFill>
+                            <a:srgbClr val="028090"/>
+                          </a:solidFill>
+                          <a:latin typeface="Arial" pitchFamily="34" charset="0"/>
+                          <a:ea typeface="Arial" pitchFamily="34" charset="-122"/>
+                          <a:cs typeface="Arial" pitchFamily="34" charset="-120"/>
+                        </a:rPr>
+                        <a:t>✓  </a:t>
+                      </a:r>
+                      <a:pPr indent="0" marL="0">
+                        <a:buNone/>
+                      </a:pPr>
+                      <a:r>
+                        <a:rPr lang="en-US" sz="1100" dirty="0">
                           <a:solidFill>
                             <a:srgbClr val="1B2A35"/>
                           </a:solidFill>
@@ -10553,7 +11674,7 @@
                         </a:rPr>
                         <a:t>On-demand Mermaid flowcharts &amp; IGOE views</a:t>
                       </a:r>
-                      <a:endParaRPr lang="en-US" sz="1150" dirty="0">
+                      <a:endParaRPr lang="en-US" sz="1100" dirty="0">
                         <a:latin typeface="Arial" charset="0"/>
                         <a:ea typeface="Arial" charset="0"/>
                         <a:cs typeface="Arial" charset="0"/>

</xml_diff>